<commit_message>
ADD pdfs and jlcpcb stackups
</commit_message>
<xml_diff>
--- a/slides/lezione5.pptx
+++ b/slides/lezione5.pptx
@@ -5,16 +5,33 @@
     <p:sldMasterId id="2147483648" r:id="rId1"/>
   </p:sldMasterIdLst>
   <p:notesMasterIdLst>
-    <p:notesMasterId r:id="rId9"/>
+    <p:notesMasterId r:id="rId26"/>
   </p:notesMasterIdLst>
   <p:sldIdLst>
     <p:sldId id="256" r:id="rId2"/>
     <p:sldId id="257" r:id="rId3"/>
-    <p:sldId id="258" r:id="rId4"/>
-    <p:sldId id="259" r:id="rId5"/>
-    <p:sldId id="260" r:id="rId6"/>
-    <p:sldId id="261" r:id="rId7"/>
-    <p:sldId id="262" r:id="rId8"/>
+    <p:sldId id="276" r:id="rId4"/>
+    <p:sldId id="277" r:id="rId5"/>
+    <p:sldId id="265" r:id="rId6"/>
+    <p:sldId id="278" r:id="rId7"/>
+    <p:sldId id="279" r:id="rId8"/>
+    <p:sldId id="269" r:id="rId9"/>
+    <p:sldId id="268" r:id="rId10"/>
+    <p:sldId id="274" r:id="rId11"/>
+    <p:sldId id="275" r:id="rId12"/>
+    <p:sldId id="267" r:id="rId13"/>
+    <p:sldId id="266" r:id="rId14"/>
+    <p:sldId id="264" r:id="rId15"/>
+    <p:sldId id="263" r:id="rId16"/>
+    <p:sldId id="271" r:id="rId17"/>
+    <p:sldId id="272" r:id="rId18"/>
+    <p:sldId id="273" r:id="rId19"/>
+    <p:sldId id="270" r:id="rId20"/>
+    <p:sldId id="258" r:id="rId21"/>
+    <p:sldId id="259" r:id="rId22"/>
+    <p:sldId id="260" r:id="rId23"/>
+    <p:sldId id="261" r:id="rId24"/>
+    <p:sldId id="262" r:id="rId25"/>
   </p:sldIdLst>
   <p:sldSz cx="12192000" cy="6858000"/>
   <p:notesSz cx="6858000" cy="9144000"/>
@@ -203,7 +220,7 @@
           <a:p>
             <a:fld id="{E39E4411-F617-6844-B543-1D0C1529BD09}" type="datetimeFigureOut">
               <a:rPr lang="en-US" smtClean="0"/>
-              <a:t>12/19/25</a:t>
+              <a:t>1/12/26</a:t>
             </a:fld>
             <a:endParaRPr lang="en-US"/>
           </a:p>
@@ -3737,7 +3754,7 @@
           <a:p>
             <a:r>
               <a:rPr lang="it-IT" noProof="0" dirty="0"/>
-              <a:t>Lezione 5</a:t>
+              <a:t>Labs</a:t>
             </a:r>
           </a:p>
         </p:txBody>
@@ -3870,6 +3887,1752 @@
     <p:extLst>
       <p:ext uri="{BB962C8B-B14F-4D97-AF65-F5344CB8AC3E}">
         <p14:creationId xmlns:p14="http://schemas.microsoft.com/office/powerpoint/2010/main" val="487565242"/>
+      </p:ext>
+    </p:extLst>
+  </p:cSld>
+  <p:clrMapOvr>
+    <a:masterClrMapping/>
+  </p:clrMapOvr>
+</p:sld>
+</file>
+
+<file path=ppt/slides/slide10.xml><?xml version="1.0" encoding="utf-8"?>
+<p:sld xmlns:a="http://schemas.openxmlformats.org/drawingml/2006/main" xmlns:r="http://schemas.openxmlformats.org/officeDocument/2006/relationships" xmlns:p="http://schemas.openxmlformats.org/presentationml/2006/main">
+  <p:cSld>
+    <p:spTree>
+      <p:nvGrpSpPr>
+        <p:cNvPr id="1" name=""/>
+        <p:cNvGrpSpPr/>
+        <p:nvPr/>
+      </p:nvGrpSpPr>
+      <p:grpSpPr>
+        <a:xfrm>
+          <a:off x="0" y="0"/>
+          <a:ext cx="0" cy="0"/>
+          <a:chOff x="0" y="0"/>
+          <a:chExt cx="0" cy="0"/>
+        </a:xfrm>
+      </p:grpSpPr>
+      <p:sp>
+        <p:nvSpPr>
+          <p:cNvPr id="2" name="Title 1">
+            <a:extLst>
+              <a:ext uri="{FF2B5EF4-FFF2-40B4-BE49-F238E27FC236}">
+                <a16:creationId xmlns:a16="http://schemas.microsoft.com/office/drawing/2014/main" id="{5136FC17-A015-AAA3-E6FB-F8F5390B2C68}"/>
+              </a:ext>
+            </a:extLst>
+          </p:cNvPr>
+          <p:cNvSpPr>
+            <a:spLocks noGrp="1"/>
+          </p:cNvSpPr>
+          <p:nvPr>
+            <p:ph type="title"/>
+          </p:nvPr>
+        </p:nvSpPr>
+        <p:spPr/>
+        <p:txBody>
+          <a:bodyPr/>
+          <a:lstStyle/>
+          <a:p>
+            <a:endParaRPr lang="en-US"/>
+          </a:p>
+        </p:txBody>
+      </p:sp>
+      <p:sp>
+        <p:nvSpPr>
+          <p:cNvPr id="3" name="Date Placeholder 2">
+            <a:extLst>
+              <a:ext uri="{FF2B5EF4-FFF2-40B4-BE49-F238E27FC236}">
+                <a16:creationId xmlns:a16="http://schemas.microsoft.com/office/drawing/2014/main" id="{C3676A21-5ED7-CC82-EBED-147ECA3FAA29}"/>
+              </a:ext>
+            </a:extLst>
+          </p:cNvPr>
+          <p:cNvSpPr>
+            <a:spLocks noGrp="1"/>
+          </p:cNvSpPr>
+          <p:nvPr>
+            <p:ph type="dt" sz="half" idx="10"/>
+          </p:nvPr>
+        </p:nvSpPr>
+        <p:spPr/>
+        <p:txBody>
+          <a:bodyPr/>
+          <a:lstStyle/>
+          <a:p>
+            <a:r>
+              <a:rPr lang="en-US"/>
+              <a:t>22/01/2026</a:t>
+            </a:r>
+          </a:p>
+        </p:txBody>
+      </p:sp>
+      <p:sp>
+        <p:nvSpPr>
+          <p:cNvPr id="4" name="Footer Placeholder 3">
+            <a:extLst>
+              <a:ext uri="{FF2B5EF4-FFF2-40B4-BE49-F238E27FC236}">
+                <a16:creationId xmlns:a16="http://schemas.microsoft.com/office/drawing/2014/main" id="{02206D97-3B6D-F1A7-7203-D605D4CB1765}"/>
+              </a:ext>
+            </a:extLst>
+          </p:cNvPr>
+          <p:cNvSpPr>
+            <a:spLocks noGrp="1"/>
+          </p:cNvSpPr>
+          <p:nvPr>
+            <p:ph type="ftr" sz="quarter" idx="11"/>
+          </p:nvPr>
+        </p:nvSpPr>
+        <p:spPr/>
+        <p:txBody>
+          <a:bodyPr/>
+          <a:lstStyle/>
+          <a:p>
+            <a:r>
+              <a:rPr lang="en-US"/>
+              <a:t>Stefan Cristi Zugravel, elettronica base, TPS lezione 5</a:t>
+            </a:r>
+          </a:p>
+        </p:txBody>
+      </p:sp>
+      <p:sp>
+        <p:nvSpPr>
+          <p:cNvPr id="5" name="Slide Number Placeholder 4">
+            <a:extLst>
+              <a:ext uri="{FF2B5EF4-FFF2-40B4-BE49-F238E27FC236}">
+                <a16:creationId xmlns:a16="http://schemas.microsoft.com/office/drawing/2014/main" id="{A52D3836-468A-9F17-BF0A-785B90A4DA2C}"/>
+              </a:ext>
+            </a:extLst>
+          </p:cNvPr>
+          <p:cNvSpPr>
+            <a:spLocks noGrp="1"/>
+          </p:cNvSpPr>
+          <p:nvPr>
+            <p:ph type="sldNum" sz="quarter" idx="12"/>
+          </p:nvPr>
+        </p:nvSpPr>
+        <p:spPr/>
+        <p:txBody>
+          <a:bodyPr/>
+          <a:lstStyle/>
+          <a:p>
+            <a:fld id="{B7C12E76-5DE4-834B-BE10-AD31AA7B20EC}" type="slidenum">
+              <a:rPr lang="en-US" smtClean="0"/>
+              <a:t>10</a:t>
+            </a:fld>
+            <a:endParaRPr lang="en-US"/>
+          </a:p>
+        </p:txBody>
+      </p:sp>
+      <p:pic>
+        <p:nvPicPr>
+          <p:cNvPr id="7" name="Picture 6" descr="A black text on a white background&#10;&#10;AI-generated content may be incorrect.">
+            <a:extLst>
+              <a:ext uri="{FF2B5EF4-FFF2-40B4-BE49-F238E27FC236}">
+                <a16:creationId xmlns:a16="http://schemas.microsoft.com/office/drawing/2014/main" id="{1D0466C7-6C34-A14C-9BA6-24D8E4BB53E0}"/>
+              </a:ext>
+            </a:extLst>
+          </p:cNvPr>
+          <p:cNvPicPr>
+            <a:picLocks noChangeAspect="1"/>
+          </p:cNvPicPr>
+          <p:nvPr/>
+        </p:nvPicPr>
+        <p:blipFill>
+          <a:blip r:embed="rId2"/>
+          <a:stretch>
+            <a:fillRect/>
+          </a:stretch>
+        </p:blipFill>
+        <p:spPr>
+          <a:xfrm>
+            <a:off x="0" y="1256926"/>
+            <a:ext cx="3962400" cy="1206500"/>
+          </a:xfrm>
+          <a:prstGeom prst="rect">
+            <a:avLst/>
+          </a:prstGeom>
+        </p:spPr>
+      </p:pic>
+      <p:pic>
+        <p:nvPicPr>
+          <p:cNvPr id="9" name="Picture 8" descr="A screen shot of a computer&#10;&#10;AI-generated content may be incorrect.">
+            <a:extLst>
+              <a:ext uri="{FF2B5EF4-FFF2-40B4-BE49-F238E27FC236}">
+                <a16:creationId xmlns:a16="http://schemas.microsoft.com/office/drawing/2014/main" id="{6FE93DFA-7ABC-AF6D-AF19-6F87265BBD50}"/>
+              </a:ext>
+            </a:extLst>
+          </p:cNvPr>
+          <p:cNvPicPr>
+            <a:picLocks noChangeAspect="1"/>
+          </p:cNvPicPr>
+          <p:nvPr/>
+        </p:nvPicPr>
+        <p:blipFill>
+          <a:blip r:embed="rId3"/>
+          <a:stretch>
+            <a:fillRect/>
+          </a:stretch>
+        </p:blipFill>
+        <p:spPr>
+          <a:xfrm>
+            <a:off x="472916" y="2678814"/>
+            <a:ext cx="11246167" cy="3431522"/>
+          </a:xfrm>
+          <a:prstGeom prst="rect">
+            <a:avLst/>
+          </a:prstGeom>
+        </p:spPr>
+      </p:pic>
+    </p:spTree>
+    <p:extLst>
+      <p:ext uri="{BB962C8B-B14F-4D97-AF65-F5344CB8AC3E}">
+        <p14:creationId xmlns:p14="http://schemas.microsoft.com/office/powerpoint/2010/main" val="3334437832"/>
+      </p:ext>
+    </p:extLst>
+  </p:cSld>
+  <p:clrMapOvr>
+    <a:masterClrMapping/>
+  </p:clrMapOvr>
+</p:sld>
+</file>
+
+<file path=ppt/slides/slide11.xml><?xml version="1.0" encoding="utf-8"?>
+<p:sld xmlns:a="http://schemas.openxmlformats.org/drawingml/2006/main" xmlns:r="http://schemas.openxmlformats.org/officeDocument/2006/relationships" xmlns:p="http://schemas.openxmlformats.org/presentationml/2006/main">
+  <p:cSld>
+    <p:spTree>
+      <p:nvGrpSpPr>
+        <p:cNvPr id="1" name=""/>
+        <p:cNvGrpSpPr/>
+        <p:nvPr/>
+      </p:nvGrpSpPr>
+      <p:grpSpPr>
+        <a:xfrm>
+          <a:off x="0" y="0"/>
+          <a:ext cx="0" cy="0"/>
+          <a:chOff x="0" y="0"/>
+          <a:chExt cx="0" cy="0"/>
+        </a:xfrm>
+      </p:grpSpPr>
+      <p:sp>
+        <p:nvSpPr>
+          <p:cNvPr id="2" name="Title 1">
+            <a:extLst>
+              <a:ext uri="{FF2B5EF4-FFF2-40B4-BE49-F238E27FC236}">
+                <a16:creationId xmlns:a16="http://schemas.microsoft.com/office/drawing/2014/main" id="{85E3C7B8-3261-D2F7-2555-3E3CA021EB27}"/>
+              </a:ext>
+            </a:extLst>
+          </p:cNvPr>
+          <p:cNvSpPr>
+            <a:spLocks noGrp="1"/>
+          </p:cNvSpPr>
+          <p:nvPr>
+            <p:ph type="title"/>
+          </p:nvPr>
+        </p:nvSpPr>
+        <p:spPr/>
+        <p:txBody>
+          <a:bodyPr/>
+          <a:lstStyle/>
+          <a:p>
+            <a:endParaRPr lang="en-US"/>
+          </a:p>
+        </p:txBody>
+      </p:sp>
+      <p:sp>
+        <p:nvSpPr>
+          <p:cNvPr id="3" name="Date Placeholder 2">
+            <a:extLst>
+              <a:ext uri="{FF2B5EF4-FFF2-40B4-BE49-F238E27FC236}">
+                <a16:creationId xmlns:a16="http://schemas.microsoft.com/office/drawing/2014/main" id="{DC750AE2-6804-3DFA-B635-EB8B9B6F48B7}"/>
+              </a:ext>
+            </a:extLst>
+          </p:cNvPr>
+          <p:cNvSpPr>
+            <a:spLocks noGrp="1"/>
+          </p:cNvSpPr>
+          <p:nvPr>
+            <p:ph type="dt" sz="half" idx="10"/>
+          </p:nvPr>
+        </p:nvSpPr>
+        <p:spPr/>
+        <p:txBody>
+          <a:bodyPr/>
+          <a:lstStyle/>
+          <a:p>
+            <a:r>
+              <a:rPr lang="en-US"/>
+              <a:t>22/01/2026</a:t>
+            </a:r>
+          </a:p>
+        </p:txBody>
+      </p:sp>
+      <p:sp>
+        <p:nvSpPr>
+          <p:cNvPr id="4" name="Footer Placeholder 3">
+            <a:extLst>
+              <a:ext uri="{FF2B5EF4-FFF2-40B4-BE49-F238E27FC236}">
+                <a16:creationId xmlns:a16="http://schemas.microsoft.com/office/drawing/2014/main" id="{02203F90-FCC2-EECE-97EF-0BFA7FD09CC5}"/>
+              </a:ext>
+            </a:extLst>
+          </p:cNvPr>
+          <p:cNvSpPr>
+            <a:spLocks noGrp="1"/>
+          </p:cNvSpPr>
+          <p:nvPr>
+            <p:ph type="ftr" sz="quarter" idx="11"/>
+          </p:nvPr>
+        </p:nvSpPr>
+        <p:spPr/>
+        <p:txBody>
+          <a:bodyPr/>
+          <a:lstStyle/>
+          <a:p>
+            <a:r>
+              <a:rPr lang="en-US"/>
+              <a:t>Stefan Cristi Zugravel, elettronica base, TPS lezione 5</a:t>
+            </a:r>
+          </a:p>
+        </p:txBody>
+      </p:sp>
+      <p:sp>
+        <p:nvSpPr>
+          <p:cNvPr id="5" name="Slide Number Placeholder 4">
+            <a:extLst>
+              <a:ext uri="{FF2B5EF4-FFF2-40B4-BE49-F238E27FC236}">
+                <a16:creationId xmlns:a16="http://schemas.microsoft.com/office/drawing/2014/main" id="{D0E4B8C0-4325-BA22-5828-5616730C9952}"/>
+              </a:ext>
+            </a:extLst>
+          </p:cNvPr>
+          <p:cNvSpPr>
+            <a:spLocks noGrp="1"/>
+          </p:cNvSpPr>
+          <p:nvPr>
+            <p:ph type="sldNum" sz="quarter" idx="12"/>
+          </p:nvPr>
+        </p:nvSpPr>
+        <p:spPr/>
+        <p:txBody>
+          <a:bodyPr/>
+          <a:lstStyle/>
+          <a:p>
+            <a:fld id="{B7C12E76-5DE4-834B-BE10-AD31AA7B20EC}" type="slidenum">
+              <a:rPr lang="en-US" smtClean="0"/>
+              <a:t>11</a:t>
+            </a:fld>
+            <a:endParaRPr lang="en-US"/>
+          </a:p>
+        </p:txBody>
+      </p:sp>
+      <p:pic>
+        <p:nvPicPr>
+          <p:cNvPr id="7" name="Picture 6" descr="A table of software programs&#10;&#10;AI-generated content may be incorrect.">
+            <a:extLst>
+              <a:ext uri="{FF2B5EF4-FFF2-40B4-BE49-F238E27FC236}">
+                <a16:creationId xmlns:a16="http://schemas.microsoft.com/office/drawing/2014/main" id="{E5280D38-BD80-CFB8-2AC6-B8DBD38FF4E1}"/>
+              </a:ext>
+            </a:extLst>
+          </p:cNvPr>
+          <p:cNvPicPr>
+            <a:picLocks noChangeAspect="1"/>
+          </p:cNvPicPr>
+          <p:nvPr/>
+        </p:nvPicPr>
+        <p:blipFill>
+          <a:blip r:embed="rId2"/>
+          <a:stretch>
+            <a:fillRect/>
+          </a:stretch>
+        </p:blipFill>
+        <p:spPr>
+          <a:xfrm>
+            <a:off x="2924213" y="1074703"/>
+            <a:ext cx="6318171" cy="5281647"/>
+          </a:xfrm>
+          <a:prstGeom prst="rect">
+            <a:avLst/>
+          </a:prstGeom>
+        </p:spPr>
+      </p:pic>
+    </p:spTree>
+    <p:extLst>
+      <p:ext uri="{BB962C8B-B14F-4D97-AF65-F5344CB8AC3E}">
+        <p14:creationId xmlns:p14="http://schemas.microsoft.com/office/powerpoint/2010/main" val="1176803700"/>
+      </p:ext>
+    </p:extLst>
+  </p:cSld>
+  <p:clrMapOvr>
+    <a:masterClrMapping/>
+  </p:clrMapOvr>
+</p:sld>
+</file>
+
+<file path=ppt/slides/slide12.xml><?xml version="1.0" encoding="utf-8"?>
+<p:sld xmlns:a="http://schemas.openxmlformats.org/drawingml/2006/main" xmlns:r="http://schemas.openxmlformats.org/officeDocument/2006/relationships" xmlns:p="http://schemas.openxmlformats.org/presentationml/2006/main">
+  <p:cSld>
+    <p:spTree>
+      <p:nvGrpSpPr>
+        <p:cNvPr id="1" name="">
+          <a:extLst>
+            <a:ext uri="{FF2B5EF4-FFF2-40B4-BE49-F238E27FC236}">
+              <a16:creationId xmlns:a16="http://schemas.microsoft.com/office/drawing/2014/main" id="{954ED433-5DBC-85E5-3978-AD0F53EE65A5}"/>
+            </a:ext>
+          </a:extLst>
+        </p:cNvPr>
+        <p:cNvGrpSpPr/>
+        <p:nvPr/>
+      </p:nvGrpSpPr>
+      <p:grpSpPr>
+        <a:xfrm>
+          <a:off x="0" y="0"/>
+          <a:ext cx="0" cy="0"/>
+          <a:chOff x="0" y="0"/>
+          <a:chExt cx="0" cy="0"/>
+        </a:xfrm>
+      </p:grpSpPr>
+      <p:sp>
+        <p:nvSpPr>
+          <p:cNvPr id="2" name="Title 1">
+            <a:extLst>
+              <a:ext uri="{FF2B5EF4-FFF2-40B4-BE49-F238E27FC236}">
+                <a16:creationId xmlns:a16="http://schemas.microsoft.com/office/drawing/2014/main" id="{ABE51305-B753-5985-9F55-56C78FB82FE9}"/>
+              </a:ext>
+            </a:extLst>
+          </p:cNvPr>
+          <p:cNvSpPr>
+            <a:spLocks noGrp="1"/>
+          </p:cNvSpPr>
+          <p:nvPr>
+            <p:ph type="title"/>
+          </p:nvPr>
+        </p:nvSpPr>
+        <p:spPr>
+          <a:xfrm>
+            <a:off x="152397" y="136525"/>
+            <a:ext cx="11861805" cy="2418415"/>
+          </a:xfrm>
+        </p:spPr>
+        <p:txBody>
+          <a:bodyPr anchor="t">
+            <a:normAutofit/>
+          </a:bodyPr>
+          <a:lstStyle/>
+          <a:p>
+            <a:r>
+              <a:rPr lang="en-US" dirty="0"/>
+              <a:t>Lab 4</a:t>
+            </a:r>
+            <a:br>
+              <a:rPr lang="en-US" dirty="0"/>
+            </a:br>
+            <a:r>
+              <a:rPr lang="en-US" dirty="0"/>
+              <a:t>Length tuning and de-skewing in </a:t>
+            </a:r>
+            <a:r>
+              <a:rPr lang="en-US" dirty="0" err="1"/>
+              <a:t>KiCAD</a:t>
+            </a:r>
+            <a:endParaRPr lang="en-US" dirty="0"/>
+          </a:p>
+        </p:txBody>
+      </p:sp>
+      <p:sp>
+        <p:nvSpPr>
+          <p:cNvPr id="3" name="Date Placeholder 2">
+            <a:extLst>
+              <a:ext uri="{FF2B5EF4-FFF2-40B4-BE49-F238E27FC236}">
+                <a16:creationId xmlns:a16="http://schemas.microsoft.com/office/drawing/2014/main" id="{7A43081B-5565-64FA-CE06-06481FC667A8}"/>
+              </a:ext>
+            </a:extLst>
+          </p:cNvPr>
+          <p:cNvSpPr>
+            <a:spLocks noGrp="1"/>
+          </p:cNvSpPr>
+          <p:nvPr>
+            <p:ph type="dt" sz="half" idx="10"/>
+          </p:nvPr>
+        </p:nvSpPr>
+        <p:spPr/>
+        <p:txBody>
+          <a:bodyPr/>
+          <a:lstStyle/>
+          <a:p>
+            <a:r>
+              <a:rPr lang="en-US"/>
+              <a:t>22/01/2026</a:t>
+            </a:r>
+          </a:p>
+        </p:txBody>
+      </p:sp>
+      <p:sp>
+        <p:nvSpPr>
+          <p:cNvPr id="4" name="Footer Placeholder 3">
+            <a:extLst>
+              <a:ext uri="{FF2B5EF4-FFF2-40B4-BE49-F238E27FC236}">
+                <a16:creationId xmlns:a16="http://schemas.microsoft.com/office/drawing/2014/main" id="{9615CABA-3F62-C733-ABBE-98E829A32D27}"/>
+              </a:ext>
+            </a:extLst>
+          </p:cNvPr>
+          <p:cNvSpPr>
+            <a:spLocks noGrp="1"/>
+          </p:cNvSpPr>
+          <p:nvPr>
+            <p:ph type="ftr" sz="quarter" idx="11"/>
+          </p:nvPr>
+        </p:nvSpPr>
+        <p:spPr/>
+        <p:txBody>
+          <a:bodyPr/>
+          <a:lstStyle/>
+          <a:p>
+            <a:r>
+              <a:rPr lang="en-US"/>
+              <a:t>Stefan Cristi Zugravel, elettronica base, TPS lezione 5</a:t>
+            </a:r>
+          </a:p>
+        </p:txBody>
+      </p:sp>
+      <p:sp>
+        <p:nvSpPr>
+          <p:cNvPr id="5" name="Slide Number Placeholder 4">
+            <a:extLst>
+              <a:ext uri="{FF2B5EF4-FFF2-40B4-BE49-F238E27FC236}">
+                <a16:creationId xmlns:a16="http://schemas.microsoft.com/office/drawing/2014/main" id="{82217CE1-2648-81C5-0343-8A5085EA6EE2}"/>
+              </a:ext>
+            </a:extLst>
+          </p:cNvPr>
+          <p:cNvSpPr>
+            <a:spLocks noGrp="1"/>
+          </p:cNvSpPr>
+          <p:nvPr>
+            <p:ph type="sldNum" sz="quarter" idx="12"/>
+          </p:nvPr>
+        </p:nvSpPr>
+        <p:spPr/>
+        <p:txBody>
+          <a:bodyPr/>
+          <a:lstStyle/>
+          <a:p>
+            <a:fld id="{B7C12E76-5DE4-834B-BE10-AD31AA7B20EC}" type="slidenum">
+              <a:rPr lang="en-US" smtClean="0"/>
+              <a:t>12</a:t>
+            </a:fld>
+            <a:endParaRPr lang="en-US"/>
+          </a:p>
+        </p:txBody>
+      </p:sp>
+    </p:spTree>
+    <p:extLst>
+      <p:ext uri="{BB962C8B-B14F-4D97-AF65-F5344CB8AC3E}">
+        <p14:creationId xmlns:p14="http://schemas.microsoft.com/office/powerpoint/2010/main" val="4102696029"/>
+      </p:ext>
+    </p:extLst>
+  </p:cSld>
+  <p:clrMapOvr>
+    <a:masterClrMapping/>
+  </p:clrMapOvr>
+</p:sld>
+</file>
+
+<file path=ppt/slides/slide13.xml><?xml version="1.0" encoding="utf-8"?>
+<p:sld xmlns:a="http://schemas.openxmlformats.org/drawingml/2006/main" xmlns:r="http://schemas.openxmlformats.org/officeDocument/2006/relationships" xmlns:p="http://schemas.openxmlformats.org/presentationml/2006/main">
+  <p:cSld>
+    <p:spTree>
+      <p:nvGrpSpPr>
+        <p:cNvPr id="1" name="">
+          <a:extLst>
+            <a:ext uri="{FF2B5EF4-FFF2-40B4-BE49-F238E27FC236}">
+              <a16:creationId xmlns:a16="http://schemas.microsoft.com/office/drawing/2014/main" id="{BB4B2F64-A2D1-5691-A421-9ACC80B193BB}"/>
+            </a:ext>
+          </a:extLst>
+        </p:cNvPr>
+        <p:cNvGrpSpPr/>
+        <p:nvPr/>
+      </p:nvGrpSpPr>
+      <p:grpSpPr>
+        <a:xfrm>
+          <a:off x="0" y="0"/>
+          <a:ext cx="0" cy="0"/>
+          <a:chOff x="0" y="0"/>
+          <a:chExt cx="0" cy="0"/>
+        </a:xfrm>
+      </p:grpSpPr>
+      <p:sp>
+        <p:nvSpPr>
+          <p:cNvPr id="2" name="Title 1">
+            <a:extLst>
+              <a:ext uri="{FF2B5EF4-FFF2-40B4-BE49-F238E27FC236}">
+                <a16:creationId xmlns:a16="http://schemas.microsoft.com/office/drawing/2014/main" id="{B7D7C4D9-FCF5-88B5-3820-FE70E1D3D45D}"/>
+              </a:ext>
+            </a:extLst>
+          </p:cNvPr>
+          <p:cNvSpPr>
+            <a:spLocks noGrp="1"/>
+          </p:cNvSpPr>
+          <p:nvPr>
+            <p:ph type="title"/>
+          </p:nvPr>
+        </p:nvSpPr>
+        <p:spPr>
+          <a:xfrm>
+            <a:off x="152397" y="136526"/>
+            <a:ext cx="11861805" cy="2274980"/>
+          </a:xfrm>
+        </p:spPr>
+        <p:txBody>
+          <a:bodyPr anchor="t">
+            <a:normAutofit/>
+          </a:bodyPr>
+          <a:lstStyle/>
+          <a:p>
+            <a:r>
+              <a:rPr lang="en-US" dirty="0"/>
+              <a:t>Lab 5</a:t>
+            </a:r>
+            <a:br>
+              <a:rPr lang="en-US" dirty="0"/>
+            </a:br>
+            <a:r>
+              <a:rPr lang="en-US" dirty="0"/>
+              <a:t>BCD counter in VHDL and </a:t>
+            </a:r>
+            <a:r>
+              <a:rPr lang="en-US" dirty="0" err="1"/>
+              <a:t>differnt</a:t>
+            </a:r>
+            <a:r>
+              <a:rPr lang="en-US" dirty="0"/>
+              <a:t> ways of dividing clock</a:t>
+            </a:r>
+          </a:p>
+        </p:txBody>
+      </p:sp>
+      <p:sp>
+        <p:nvSpPr>
+          <p:cNvPr id="3" name="Date Placeholder 2">
+            <a:extLst>
+              <a:ext uri="{FF2B5EF4-FFF2-40B4-BE49-F238E27FC236}">
+                <a16:creationId xmlns:a16="http://schemas.microsoft.com/office/drawing/2014/main" id="{AC9D61D5-B01A-F7F9-70F3-CEB72BC2E9FD}"/>
+              </a:ext>
+            </a:extLst>
+          </p:cNvPr>
+          <p:cNvSpPr>
+            <a:spLocks noGrp="1"/>
+          </p:cNvSpPr>
+          <p:nvPr>
+            <p:ph type="dt" sz="half" idx="10"/>
+          </p:nvPr>
+        </p:nvSpPr>
+        <p:spPr/>
+        <p:txBody>
+          <a:bodyPr/>
+          <a:lstStyle/>
+          <a:p>
+            <a:r>
+              <a:rPr lang="en-US"/>
+              <a:t>22/01/2026</a:t>
+            </a:r>
+          </a:p>
+        </p:txBody>
+      </p:sp>
+      <p:sp>
+        <p:nvSpPr>
+          <p:cNvPr id="4" name="Footer Placeholder 3">
+            <a:extLst>
+              <a:ext uri="{FF2B5EF4-FFF2-40B4-BE49-F238E27FC236}">
+                <a16:creationId xmlns:a16="http://schemas.microsoft.com/office/drawing/2014/main" id="{FEE20B62-9E4F-8C03-D55B-615B8101778C}"/>
+              </a:ext>
+            </a:extLst>
+          </p:cNvPr>
+          <p:cNvSpPr>
+            <a:spLocks noGrp="1"/>
+          </p:cNvSpPr>
+          <p:nvPr>
+            <p:ph type="ftr" sz="quarter" idx="11"/>
+          </p:nvPr>
+        </p:nvSpPr>
+        <p:spPr/>
+        <p:txBody>
+          <a:bodyPr/>
+          <a:lstStyle/>
+          <a:p>
+            <a:r>
+              <a:rPr lang="en-US"/>
+              <a:t>Stefan Cristi Zugravel, elettronica base, TPS lezione 5</a:t>
+            </a:r>
+          </a:p>
+        </p:txBody>
+      </p:sp>
+      <p:sp>
+        <p:nvSpPr>
+          <p:cNvPr id="5" name="Slide Number Placeholder 4">
+            <a:extLst>
+              <a:ext uri="{FF2B5EF4-FFF2-40B4-BE49-F238E27FC236}">
+                <a16:creationId xmlns:a16="http://schemas.microsoft.com/office/drawing/2014/main" id="{95DE69AC-3856-7258-6C10-8F27A650D0EA}"/>
+              </a:ext>
+            </a:extLst>
+          </p:cNvPr>
+          <p:cNvSpPr>
+            <a:spLocks noGrp="1"/>
+          </p:cNvSpPr>
+          <p:nvPr>
+            <p:ph type="sldNum" sz="quarter" idx="12"/>
+          </p:nvPr>
+        </p:nvSpPr>
+        <p:spPr/>
+        <p:txBody>
+          <a:bodyPr/>
+          <a:lstStyle/>
+          <a:p>
+            <a:fld id="{B7C12E76-5DE4-834B-BE10-AD31AA7B20EC}" type="slidenum">
+              <a:rPr lang="en-US" smtClean="0"/>
+              <a:t>13</a:t>
+            </a:fld>
+            <a:endParaRPr lang="en-US"/>
+          </a:p>
+        </p:txBody>
+      </p:sp>
+    </p:spTree>
+    <p:extLst>
+      <p:ext uri="{BB962C8B-B14F-4D97-AF65-F5344CB8AC3E}">
+        <p14:creationId xmlns:p14="http://schemas.microsoft.com/office/powerpoint/2010/main" val="3470688451"/>
+      </p:ext>
+    </p:extLst>
+  </p:cSld>
+  <p:clrMapOvr>
+    <a:masterClrMapping/>
+  </p:clrMapOvr>
+</p:sld>
+</file>
+
+<file path=ppt/slides/slide14.xml><?xml version="1.0" encoding="utf-8"?>
+<p:sld xmlns:a="http://schemas.openxmlformats.org/drawingml/2006/main" xmlns:r="http://schemas.openxmlformats.org/officeDocument/2006/relationships" xmlns:p="http://schemas.openxmlformats.org/presentationml/2006/main">
+  <p:cSld>
+    <p:spTree>
+      <p:nvGrpSpPr>
+        <p:cNvPr id="1" name="">
+          <a:extLst>
+            <a:ext uri="{FF2B5EF4-FFF2-40B4-BE49-F238E27FC236}">
+              <a16:creationId xmlns:a16="http://schemas.microsoft.com/office/drawing/2014/main" id="{7079B1F0-74E2-7108-008D-611863C118D4}"/>
+            </a:ext>
+          </a:extLst>
+        </p:cNvPr>
+        <p:cNvGrpSpPr/>
+        <p:nvPr/>
+      </p:nvGrpSpPr>
+      <p:grpSpPr>
+        <a:xfrm>
+          <a:off x="0" y="0"/>
+          <a:ext cx="0" cy="0"/>
+          <a:chOff x="0" y="0"/>
+          <a:chExt cx="0" cy="0"/>
+        </a:xfrm>
+      </p:grpSpPr>
+      <p:sp>
+        <p:nvSpPr>
+          <p:cNvPr id="2" name="Title 1">
+            <a:extLst>
+              <a:ext uri="{FF2B5EF4-FFF2-40B4-BE49-F238E27FC236}">
+                <a16:creationId xmlns:a16="http://schemas.microsoft.com/office/drawing/2014/main" id="{C630BD7E-27EB-26C9-D876-17194D3A6003}"/>
+              </a:ext>
+            </a:extLst>
+          </p:cNvPr>
+          <p:cNvSpPr>
+            <a:spLocks noGrp="1"/>
+          </p:cNvSpPr>
+          <p:nvPr>
+            <p:ph type="title"/>
+          </p:nvPr>
+        </p:nvSpPr>
+        <p:spPr>
+          <a:xfrm>
+            <a:off x="152397" y="136525"/>
+            <a:ext cx="11861805" cy="1961215"/>
+          </a:xfrm>
+        </p:spPr>
+        <p:txBody>
+          <a:bodyPr anchor="t">
+            <a:normAutofit/>
+          </a:bodyPr>
+          <a:lstStyle/>
+          <a:p>
+            <a:r>
+              <a:rPr lang="en-US" dirty="0"/>
+              <a:t>Lab 6</a:t>
+            </a:r>
+            <a:br>
+              <a:rPr lang="en-US" dirty="0"/>
+            </a:br>
+            <a:r>
+              <a:rPr lang="en-US" dirty="0" err="1"/>
+              <a:t>LTspice</a:t>
+            </a:r>
+            <a:r>
+              <a:rPr lang="en-US" dirty="0"/>
+              <a:t> labs</a:t>
+            </a:r>
+          </a:p>
+        </p:txBody>
+      </p:sp>
+      <p:sp>
+        <p:nvSpPr>
+          <p:cNvPr id="3" name="Date Placeholder 2">
+            <a:extLst>
+              <a:ext uri="{FF2B5EF4-FFF2-40B4-BE49-F238E27FC236}">
+                <a16:creationId xmlns:a16="http://schemas.microsoft.com/office/drawing/2014/main" id="{61120DAD-531F-6280-39D0-10C4AEF07586}"/>
+              </a:ext>
+            </a:extLst>
+          </p:cNvPr>
+          <p:cNvSpPr>
+            <a:spLocks noGrp="1"/>
+          </p:cNvSpPr>
+          <p:nvPr>
+            <p:ph type="dt" sz="half" idx="10"/>
+          </p:nvPr>
+        </p:nvSpPr>
+        <p:spPr/>
+        <p:txBody>
+          <a:bodyPr/>
+          <a:lstStyle/>
+          <a:p>
+            <a:r>
+              <a:rPr lang="en-US"/>
+              <a:t>22/01/2026</a:t>
+            </a:r>
+          </a:p>
+        </p:txBody>
+      </p:sp>
+      <p:sp>
+        <p:nvSpPr>
+          <p:cNvPr id="4" name="Footer Placeholder 3">
+            <a:extLst>
+              <a:ext uri="{FF2B5EF4-FFF2-40B4-BE49-F238E27FC236}">
+                <a16:creationId xmlns:a16="http://schemas.microsoft.com/office/drawing/2014/main" id="{E2E715B3-E7DF-4257-2527-2333614AF5FE}"/>
+              </a:ext>
+            </a:extLst>
+          </p:cNvPr>
+          <p:cNvSpPr>
+            <a:spLocks noGrp="1"/>
+          </p:cNvSpPr>
+          <p:nvPr>
+            <p:ph type="ftr" sz="quarter" idx="11"/>
+          </p:nvPr>
+        </p:nvSpPr>
+        <p:spPr/>
+        <p:txBody>
+          <a:bodyPr/>
+          <a:lstStyle/>
+          <a:p>
+            <a:r>
+              <a:rPr lang="en-US"/>
+              <a:t>Stefan Cristi Zugravel, elettronica base, TPS lezione 5</a:t>
+            </a:r>
+          </a:p>
+        </p:txBody>
+      </p:sp>
+      <p:sp>
+        <p:nvSpPr>
+          <p:cNvPr id="5" name="Slide Number Placeholder 4">
+            <a:extLst>
+              <a:ext uri="{FF2B5EF4-FFF2-40B4-BE49-F238E27FC236}">
+                <a16:creationId xmlns:a16="http://schemas.microsoft.com/office/drawing/2014/main" id="{E7E58443-1BDB-60A5-B1DD-3DDD7DECCFA4}"/>
+              </a:ext>
+            </a:extLst>
+          </p:cNvPr>
+          <p:cNvSpPr>
+            <a:spLocks noGrp="1"/>
+          </p:cNvSpPr>
+          <p:nvPr>
+            <p:ph type="sldNum" sz="quarter" idx="12"/>
+          </p:nvPr>
+        </p:nvSpPr>
+        <p:spPr/>
+        <p:txBody>
+          <a:bodyPr/>
+          <a:lstStyle/>
+          <a:p>
+            <a:fld id="{B7C12E76-5DE4-834B-BE10-AD31AA7B20EC}" type="slidenum">
+              <a:rPr lang="en-US" smtClean="0"/>
+              <a:t>14</a:t>
+            </a:fld>
+            <a:endParaRPr lang="en-US"/>
+          </a:p>
+        </p:txBody>
+      </p:sp>
+    </p:spTree>
+    <p:extLst>
+      <p:ext uri="{BB962C8B-B14F-4D97-AF65-F5344CB8AC3E}">
+        <p14:creationId xmlns:p14="http://schemas.microsoft.com/office/powerpoint/2010/main" val="1409732217"/>
+      </p:ext>
+    </p:extLst>
+  </p:cSld>
+  <p:clrMapOvr>
+    <a:masterClrMapping/>
+  </p:clrMapOvr>
+</p:sld>
+</file>
+
+<file path=ppt/slides/slide15.xml><?xml version="1.0" encoding="utf-8"?>
+<p:sld xmlns:a="http://schemas.openxmlformats.org/drawingml/2006/main" xmlns:r="http://schemas.openxmlformats.org/officeDocument/2006/relationships" xmlns:p="http://schemas.openxmlformats.org/presentationml/2006/main">
+  <p:cSld>
+    <p:spTree>
+      <p:nvGrpSpPr>
+        <p:cNvPr id="1" name="">
+          <a:extLst>
+            <a:ext uri="{FF2B5EF4-FFF2-40B4-BE49-F238E27FC236}">
+              <a16:creationId xmlns:a16="http://schemas.microsoft.com/office/drawing/2014/main" id="{E09A6599-C912-ECB8-F561-1E805528B96E}"/>
+            </a:ext>
+          </a:extLst>
+        </p:cNvPr>
+        <p:cNvGrpSpPr/>
+        <p:nvPr/>
+      </p:nvGrpSpPr>
+      <p:grpSpPr>
+        <a:xfrm>
+          <a:off x="0" y="0"/>
+          <a:ext cx="0" cy="0"/>
+          <a:chOff x="0" y="0"/>
+          <a:chExt cx="0" cy="0"/>
+        </a:xfrm>
+      </p:grpSpPr>
+      <p:sp>
+        <p:nvSpPr>
+          <p:cNvPr id="2" name="Title 1">
+            <a:extLst>
+              <a:ext uri="{FF2B5EF4-FFF2-40B4-BE49-F238E27FC236}">
+                <a16:creationId xmlns:a16="http://schemas.microsoft.com/office/drawing/2014/main" id="{7D0403A1-372A-C349-787D-FB1D52A87895}"/>
+              </a:ext>
+            </a:extLst>
+          </p:cNvPr>
+          <p:cNvSpPr>
+            <a:spLocks noGrp="1"/>
+          </p:cNvSpPr>
+          <p:nvPr>
+            <p:ph type="title"/>
+          </p:nvPr>
+        </p:nvSpPr>
+        <p:spPr>
+          <a:xfrm>
+            <a:off x="152397" y="136526"/>
+            <a:ext cx="11861805" cy="2427380"/>
+          </a:xfrm>
+        </p:spPr>
+        <p:txBody>
+          <a:bodyPr anchor="t">
+            <a:normAutofit/>
+          </a:bodyPr>
+          <a:lstStyle/>
+          <a:p>
+            <a:r>
+              <a:rPr lang="en-US" dirty="0"/>
+              <a:t>Lab 7</a:t>
+            </a:r>
+            <a:br>
+              <a:rPr lang="en-US" dirty="0"/>
+            </a:br>
+            <a:r>
+              <a:rPr lang="en-US" dirty="0"/>
+              <a:t>FIR filter and DDS compiler using FPGA</a:t>
+            </a:r>
+          </a:p>
+        </p:txBody>
+      </p:sp>
+      <p:sp>
+        <p:nvSpPr>
+          <p:cNvPr id="3" name="Date Placeholder 2">
+            <a:extLst>
+              <a:ext uri="{FF2B5EF4-FFF2-40B4-BE49-F238E27FC236}">
+                <a16:creationId xmlns:a16="http://schemas.microsoft.com/office/drawing/2014/main" id="{BA5AF600-FC3D-A8D6-FD41-85DC325EF5E4}"/>
+              </a:ext>
+            </a:extLst>
+          </p:cNvPr>
+          <p:cNvSpPr>
+            <a:spLocks noGrp="1"/>
+          </p:cNvSpPr>
+          <p:nvPr>
+            <p:ph type="dt" sz="half" idx="10"/>
+          </p:nvPr>
+        </p:nvSpPr>
+        <p:spPr/>
+        <p:txBody>
+          <a:bodyPr/>
+          <a:lstStyle/>
+          <a:p>
+            <a:r>
+              <a:rPr lang="en-US"/>
+              <a:t>22/01/2026</a:t>
+            </a:r>
+          </a:p>
+        </p:txBody>
+      </p:sp>
+      <p:sp>
+        <p:nvSpPr>
+          <p:cNvPr id="4" name="Footer Placeholder 3">
+            <a:extLst>
+              <a:ext uri="{FF2B5EF4-FFF2-40B4-BE49-F238E27FC236}">
+                <a16:creationId xmlns:a16="http://schemas.microsoft.com/office/drawing/2014/main" id="{D385C898-27C7-5AF2-9D1D-1D9B53320CD9}"/>
+              </a:ext>
+            </a:extLst>
+          </p:cNvPr>
+          <p:cNvSpPr>
+            <a:spLocks noGrp="1"/>
+          </p:cNvSpPr>
+          <p:nvPr>
+            <p:ph type="ftr" sz="quarter" idx="11"/>
+          </p:nvPr>
+        </p:nvSpPr>
+        <p:spPr/>
+        <p:txBody>
+          <a:bodyPr/>
+          <a:lstStyle/>
+          <a:p>
+            <a:r>
+              <a:rPr lang="en-US"/>
+              <a:t>Stefan Cristi Zugravel, elettronica base, TPS lezione 5</a:t>
+            </a:r>
+          </a:p>
+        </p:txBody>
+      </p:sp>
+      <p:sp>
+        <p:nvSpPr>
+          <p:cNvPr id="5" name="Slide Number Placeholder 4">
+            <a:extLst>
+              <a:ext uri="{FF2B5EF4-FFF2-40B4-BE49-F238E27FC236}">
+                <a16:creationId xmlns:a16="http://schemas.microsoft.com/office/drawing/2014/main" id="{76550A71-BB0A-DBFC-CDD6-55A8EB95B3D2}"/>
+              </a:ext>
+            </a:extLst>
+          </p:cNvPr>
+          <p:cNvSpPr>
+            <a:spLocks noGrp="1"/>
+          </p:cNvSpPr>
+          <p:nvPr>
+            <p:ph type="sldNum" sz="quarter" idx="12"/>
+          </p:nvPr>
+        </p:nvSpPr>
+        <p:spPr/>
+        <p:txBody>
+          <a:bodyPr/>
+          <a:lstStyle/>
+          <a:p>
+            <a:fld id="{B7C12E76-5DE4-834B-BE10-AD31AA7B20EC}" type="slidenum">
+              <a:rPr lang="en-US" smtClean="0"/>
+              <a:t>15</a:t>
+            </a:fld>
+            <a:endParaRPr lang="en-US"/>
+          </a:p>
+        </p:txBody>
+      </p:sp>
+    </p:spTree>
+    <p:extLst>
+      <p:ext uri="{BB962C8B-B14F-4D97-AF65-F5344CB8AC3E}">
+        <p14:creationId xmlns:p14="http://schemas.microsoft.com/office/powerpoint/2010/main" val="1570982071"/>
+      </p:ext>
+    </p:extLst>
+  </p:cSld>
+  <p:clrMapOvr>
+    <a:masterClrMapping/>
+  </p:clrMapOvr>
+</p:sld>
+</file>
+
+<file path=ppt/slides/slide16.xml><?xml version="1.0" encoding="utf-8"?>
+<p:sld xmlns:a="http://schemas.openxmlformats.org/drawingml/2006/main" xmlns:r="http://schemas.openxmlformats.org/officeDocument/2006/relationships" xmlns:p="http://schemas.openxmlformats.org/presentationml/2006/main">
+  <p:cSld>
+    <p:spTree>
+      <p:nvGrpSpPr>
+        <p:cNvPr id="1" name=""/>
+        <p:cNvGrpSpPr/>
+        <p:nvPr/>
+      </p:nvGrpSpPr>
+      <p:grpSpPr>
+        <a:xfrm>
+          <a:off x="0" y="0"/>
+          <a:ext cx="0" cy="0"/>
+          <a:chOff x="0" y="0"/>
+          <a:chExt cx="0" cy="0"/>
+        </a:xfrm>
+      </p:grpSpPr>
+      <p:sp>
+        <p:nvSpPr>
+          <p:cNvPr id="2" name="Title 1">
+            <a:extLst>
+              <a:ext uri="{FF2B5EF4-FFF2-40B4-BE49-F238E27FC236}">
+                <a16:creationId xmlns:a16="http://schemas.microsoft.com/office/drawing/2014/main" id="{4DAD2999-4971-5F35-8902-6543AABA01AD}"/>
+              </a:ext>
+            </a:extLst>
+          </p:cNvPr>
+          <p:cNvSpPr>
+            <a:spLocks noGrp="1"/>
+          </p:cNvSpPr>
+          <p:nvPr>
+            <p:ph type="title"/>
+          </p:nvPr>
+        </p:nvSpPr>
+        <p:spPr/>
+        <p:txBody>
+          <a:bodyPr/>
+          <a:lstStyle/>
+          <a:p>
+            <a:r>
+              <a:rPr lang="en-US" dirty="0"/>
+              <a:t>The filter architecture</a:t>
+            </a:r>
+          </a:p>
+        </p:txBody>
+      </p:sp>
+      <p:sp>
+        <p:nvSpPr>
+          <p:cNvPr id="3" name="Date Placeholder 2">
+            <a:extLst>
+              <a:ext uri="{FF2B5EF4-FFF2-40B4-BE49-F238E27FC236}">
+                <a16:creationId xmlns:a16="http://schemas.microsoft.com/office/drawing/2014/main" id="{D98DAE53-A301-FF57-E3AB-C3C597ADCBCE}"/>
+              </a:ext>
+            </a:extLst>
+          </p:cNvPr>
+          <p:cNvSpPr>
+            <a:spLocks noGrp="1"/>
+          </p:cNvSpPr>
+          <p:nvPr>
+            <p:ph type="dt" sz="half" idx="10"/>
+          </p:nvPr>
+        </p:nvSpPr>
+        <p:spPr/>
+        <p:txBody>
+          <a:bodyPr/>
+          <a:lstStyle/>
+          <a:p>
+            <a:r>
+              <a:rPr lang="en-US"/>
+              <a:t>22/01/2026</a:t>
+            </a:r>
+          </a:p>
+        </p:txBody>
+      </p:sp>
+      <p:sp>
+        <p:nvSpPr>
+          <p:cNvPr id="4" name="Footer Placeholder 3">
+            <a:extLst>
+              <a:ext uri="{FF2B5EF4-FFF2-40B4-BE49-F238E27FC236}">
+                <a16:creationId xmlns:a16="http://schemas.microsoft.com/office/drawing/2014/main" id="{E43AEFE3-CFE0-6C04-9DD2-FB4EAD6EA7E9}"/>
+              </a:ext>
+            </a:extLst>
+          </p:cNvPr>
+          <p:cNvSpPr>
+            <a:spLocks noGrp="1"/>
+          </p:cNvSpPr>
+          <p:nvPr>
+            <p:ph type="ftr" sz="quarter" idx="11"/>
+          </p:nvPr>
+        </p:nvSpPr>
+        <p:spPr/>
+        <p:txBody>
+          <a:bodyPr/>
+          <a:lstStyle/>
+          <a:p>
+            <a:r>
+              <a:rPr lang="en-US"/>
+              <a:t>Stefan Cristi Zugravel, elettronica base, TPS lezione 5</a:t>
+            </a:r>
+          </a:p>
+        </p:txBody>
+      </p:sp>
+      <p:sp>
+        <p:nvSpPr>
+          <p:cNvPr id="5" name="Slide Number Placeholder 4">
+            <a:extLst>
+              <a:ext uri="{FF2B5EF4-FFF2-40B4-BE49-F238E27FC236}">
+                <a16:creationId xmlns:a16="http://schemas.microsoft.com/office/drawing/2014/main" id="{7E9D5078-ADAC-37F7-3E64-9EF1A00D77ED}"/>
+              </a:ext>
+            </a:extLst>
+          </p:cNvPr>
+          <p:cNvSpPr>
+            <a:spLocks noGrp="1"/>
+          </p:cNvSpPr>
+          <p:nvPr>
+            <p:ph type="sldNum" sz="quarter" idx="12"/>
+          </p:nvPr>
+        </p:nvSpPr>
+        <p:spPr/>
+        <p:txBody>
+          <a:bodyPr/>
+          <a:lstStyle/>
+          <a:p>
+            <a:fld id="{B7C12E76-5DE4-834B-BE10-AD31AA7B20EC}" type="slidenum">
+              <a:rPr lang="en-US" smtClean="0"/>
+              <a:t>16</a:t>
+            </a:fld>
+            <a:endParaRPr lang="en-US"/>
+          </a:p>
+        </p:txBody>
+      </p:sp>
+      <p:pic>
+        <p:nvPicPr>
+          <p:cNvPr id="7" name="Picture 6" descr="A diagram of a mathematical equation&#10;&#10;AI-generated content may be incorrect.">
+            <a:extLst>
+              <a:ext uri="{FF2B5EF4-FFF2-40B4-BE49-F238E27FC236}">
+                <a16:creationId xmlns:a16="http://schemas.microsoft.com/office/drawing/2014/main" id="{9421DF22-CD4F-E714-51B9-E174AC414DB4}"/>
+              </a:ext>
+            </a:extLst>
+          </p:cNvPr>
+          <p:cNvPicPr>
+            <a:picLocks noChangeAspect="1"/>
+          </p:cNvPicPr>
+          <p:nvPr/>
+        </p:nvPicPr>
+        <p:blipFill>
+          <a:blip r:embed="rId2"/>
+          <a:stretch>
+            <a:fillRect/>
+          </a:stretch>
+        </p:blipFill>
+        <p:spPr>
+          <a:xfrm>
+            <a:off x="2209800" y="1589936"/>
+            <a:ext cx="7772400" cy="4361812"/>
+          </a:xfrm>
+          <a:prstGeom prst="rect">
+            <a:avLst/>
+          </a:prstGeom>
+        </p:spPr>
+      </p:pic>
+    </p:spTree>
+    <p:extLst>
+      <p:ext uri="{BB962C8B-B14F-4D97-AF65-F5344CB8AC3E}">
+        <p14:creationId xmlns:p14="http://schemas.microsoft.com/office/powerpoint/2010/main" val="1069481521"/>
+      </p:ext>
+    </p:extLst>
+  </p:cSld>
+  <p:clrMapOvr>
+    <a:masterClrMapping/>
+  </p:clrMapOvr>
+</p:sld>
+</file>
+
+<file path=ppt/slides/slide17.xml><?xml version="1.0" encoding="utf-8"?>
+<p:sld xmlns:a="http://schemas.openxmlformats.org/drawingml/2006/main" xmlns:r="http://schemas.openxmlformats.org/officeDocument/2006/relationships" xmlns:p="http://schemas.openxmlformats.org/presentationml/2006/main">
+  <p:cSld>
+    <p:spTree>
+      <p:nvGrpSpPr>
+        <p:cNvPr id="1" name=""/>
+        <p:cNvGrpSpPr/>
+        <p:nvPr/>
+      </p:nvGrpSpPr>
+      <p:grpSpPr>
+        <a:xfrm>
+          <a:off x="0" y="0"/>
+          <a:ext cx="0" cy="0"/>
+          <a:chOff x="0" y="0"/>
+          <a:chExt cx="0" cy="0"/>
+        </a:xfrm>
+      </p:grpSpPr>
+      <p:sp>
+        <p:nvSpPr>
+          <p:cNvPr id="2" name="Title 1">
+            <a:extLst>
+              <a:ext uri="{FF2B5EF4-FFF2-40B4-BE49-F238E27FC236}">
+                <a16:creationId xmlns:a16="http://schemas.microsoft.com/office/drawing/2014/main" id="{5BB0DDB4-749F-0847-1A16-5C833F192655}"/>
+              </a:ext>
+            </a:extLst>
+          </p:cNvPr>
+          <p:cNvSpPr>
+            <a:spLocks noGrp="1"/>
+          </p:cNvSpPr>
+          <p:nvPr>
+            <p:ph type="title"/>
+          </p:nvPr>
+        </p:nvSpPr>
+        <p:spPr/>
+        <p:txBody>
+          <a:bodyPr/>
+          <a:lstStyle/>
+          <a:p>
+            <a:endParaRPr lang="en-US" dirty="0"/>
+          </a:p>
+        </p:txBody>
+      </p:sp>
+      <p:sp>
+        <p:nvSpPr>
+          <p:cNvPr id="3" name="Date Placeholder 2">
+            <a:extLst>
+              <a:ext uri="{FF2B5EF4-FFF2-40B4-BE49-F238E27FC236}">
+                <a16:creationId xmlns:a16="http://schemas.microsoft.com/office/drawing/2014/main" id="{88894F6C-CB0F-2A95-84FC-E5D47C4288FA}"/>
+              </a:ext>
+            </a:extLst>
+          </p:cNvPr>
+          <p:cNvSpPr>
+            <a:spLocks noGrp="1"/>
+          </p:cNvSpPr>
+          <p:nvPr>
+            <p:ph type="dt" sz="half" idx="10"/>
+          </p:nvPr>
+        </p:nvSpPr>
+        <p:spPr/>
+        <p:txBody>
+          <a:bodyPr/>
+          <a:lstStyle/>
+          <a:p>
+            <a:r>
+              <a:rPr lang="en-US"/>
+              <a:t>22/01/2026</a:t>
+            </a:r>
+          </a:p>
+        </p:txBody>
+      </p:sp>
+      <p:sp>
+        <p:nvSpPr>
+          <p:cNvPr id="4" name="Footer Placeholder 3">
+            <a:extLst>
+              <a:ext uri="{FF2B5EF4-FFF2-40B4-BE49-F238E27FC236}">
+                <a16:creationId xmlns:a16="http://schemas.microsoft.com/office/drawing/2014/main" id="{1011CC7F-A24C-5C89-FC8A-7F83E01F9547}"/>
+              </a:ext>
+            </a:extLst>
+          </p:cNvPr>
+          <p:cNvSpPr>
+            <a:spLocks noGrp="1"/>
+          </p:cNvSpPr>
+          <p:nvPr>
+            <p:ph type="ftr" sz="quarter" idx="11"/>
+          </p:nvPr>
+        </p:nvSpPr>
+        <p:spPr/>
+        <p:txBody>
+          <a:bodyPr/>
+          <a:lstStyle/>
+          <a:p>
+            <a:r>
+              <a:rPr lang="en-US"/>
+              <a:t>Stefan Cristi Zugravel, elettronica base, TPS lezione 5</a:t>
+            </a:r>
+          </a:p>
+        </p:txBody>
+      </p:sp>
+      <p:sp>
+        <p:nvSpPr>
+          <p:cNvPr id="5" name="Slide Number Placeholder 4">
+            <a:extLst>
+              <a:ext uri="{FF2B5EF4-FFF2-40B4-BE49-F238E27FC236}">
+                <a16:creationId xmlns:a16="http://schemas.microsoft.com/office/drawing/2014/main" id="{16B2BD8B-8C75-FBAC-0CD1-0B7009E8D95E}"/>
+              </a:ext>
+            </a:extLst>
+          </p:cNvPr>
+          <p:cNvSpPr>
+            <a:spLocks noGrp="1"/>
+          </p:cNvSpPr>
+          <p:nvPr>
+            <p:ph type="sldNum" sz="quarter" idx="12"/>
+          </p:nvPr>
+        </p:nvSpPr>
+        <p:spPr/>
+        <p:txBody>
+          <a:bodyPr/>
+          <a:lstStyle/>
+          <a:p>
+            <a:fld id="{B7C12E76-5DE4-834B-BE10-AD31AA7B20EC}" type="slidenum">
+              <a:rPr lang="en-US" smtClean="0"/>
+              <a:t>17</a:t>
+            </a:fld>
+            <a:endParaRPr lang="en-US"/>
+          </a:p>
+        </p:txBody>
+      </p:sp>
+      <p:pic>
+        <p:nvPicPr>
+          <p:cNvPr id="7" name="Picture 6" descr="A screenshot of a computer&#10;&#10;AI-generated content may be incorrect.">
+            <a:extLst>
+              <a:ext uri="{FF2B5EF4-FFF2-40B4-BE49-F238E27FC236}">
+                <a16:creationId xmlns:a16="http://schemas.microsoft.com/office/drawing/2014/main" id="{C65583E7-2410-E1AE-788C-60BA22037B1B}"/>
+              </a:ext>
+            </a:extLst>
+          </p:cNvPr>
+          <p:cNvPicPr>
+            <a:picLocks noChangeAspect="1"/>
+          </p:cNvPicPr>
+          <p:nvPr/>
+        </p:nvPicPr>
+        <p:blipFill>
+          <a:blip r:embed="rId2"/>
+          <a:srcRect t="15531"/>
+          <a:stretch>
+            <a:fillRect/>
+          </a:stretch>
+        </p:blipFill>
+        <p:spPr>
+          <a:xfrm>
+            <a:off x="152400" y="1577788"/>
+            <a:ext cx="7772400" cy="1510852"/>
+          </a:xfrm>
+          <a:prstGeom prst="rect">
+            <a:avLst/>
+          </a:prstGeom>
+        </p:spPr>
+      </p:pic>
+      <p:pic>
+        <p:nvPicPr>
+          <p:cNvPr id="9" name="Picture 8" descr="A computer screen shot of a computer code&#10;&#10;AI-generated content may be incorrect.">
+            <a:extLst>
+              <a:ext uri="{FF2B5EF4-FFF2-40B4-BE49-F238E27FC236}">
+                <a16:creationId xmlns:a16="http://schemas.microsoft.com/office/drawing/2014/main" id="{756DDB9A-8299-3D83-7576-A69168E9F8C4}"/>
+              </a:ext>
+            </a:extLst>
+          </p:cNvPr>
+          <p:cNvPicPr>
+            <a:picLocks noChangeAspect="1"/>
+          </p:cNvPicPr>
+          <p:nvPr/>
+        </p:nvPicPr>
+        <p:blipFill>
+          <a:blip r:embed="rId3"/>
+          <a:stretch>
+            <a:fillRect/>
+          </a:stretch>
+        </p:blipFill>
+        <p:spPr>
+          <a:xfrm>
+            <a:off x="152400" y="3203319"/>
+            <a:ext cx="7772400" cy="2178873"/>
+          </a:xfrm>
+          <a:prstGeom prst="rect">
+            <a:avLst/>
+          </a:prstGeom>
+        </p:spPr>
+      </p:pic>
+    </p:spTree>
+    <p:extLst>
+      <p:ext uri="{BB962C8B-B14F-4D97-AF65-F5344CB8AC3E}">
+        <p14:creationId xmlns:p14="http://schemas.microsoft.com/office/powerpoint/2010/main" val="1122233816"/>
+      </p:ext>
+    </p:extLst>
+  </p:cSld>
+  <p:clrMapOvr>
+    <a:masterClrMapping/>
+  </p:clrMapOvr>
+</p:sld>
+</file>
+
+<file path=ppt/slides/slide18.xml><?xml version="1.0" encoding="utf-8"?>
+<p:sld xmlns:a="http://schemas.openxmlformats.org/drawingml/2006/main" xmlns:r="http://schemas.openxmlformats.org/officeDocument/2006/relationships" xmlns:p="http://schemas.openxmlformats.org/presentationml/2006/main">
+  <p:cSld>
+    <p:spTree>
+      <p:nvGrpSpPr>
+        <p:cNvPr id="1" name=""/>
+        <p:cNvGrpSpPr/>
+        <p:nvPr/>
+      </p:nvGrpSpPr>
+      <p:grpSpPr>
+        <a:xfrm>
+          <a:off x="0" y="0"/>
+          <a:ext cx="0" cy="0"/>
+          <a:chOff x="0" y="0"/>
+          <a:chExt cx="0" cy="0"/>
+        </a:xfrm>
+      </p:grpSpPr>
+      <p:sp>
+        <p:nvSpPr>
+          <p:cNvPr id="2" name="Title 1">
+            <a:extLst>
+              <a:ext uri="{FF2B5EF4-FFF2-40B4-BE49-F238E27FC236}">
+                <a16:creationId xmlns:a16="http://schemas.microsoft.com/office/drawing/2014/main" id="{F8B6378D-A4F2-B446-A7D1-A64D98D09F40}"/>
+              </a:ext>
+            </a:extLst>
+          </p:cNvPr>
+          <p:cNvSpPr>
+            <a:spLocks noGrp="1"/>
+          </p:cNvSpPr>
+          <p:nvPr>
+            <p:ph type="title"/>
+          </p:nvPr>
+        </p:nvSpPr>
+        <p:spPr/>
+        <p:txBody>
+          <a:bodyPr/>
+          <a:lstStyle/>
+          <a:p>
+            <a:endParaRPr lang="en-US"/>
+          </a:p>
+        </p:txBody>
+      </p:sp>
+      <p:sp>
+        <p:nvSpPr>
+          <p:cNvPr id="3" name="Date Placeholder 2">
+            <a:extLst>
+              <a:ext uri="{FF2B5EF4-FFF2-40B4-BE49-F238E27FC236}">
+                <a16:creationId xmlns:a16="http://schemas.microsoft.com/office/drawing/2014/main" id="{99F74959-5474-6EAF-2B4F-8441486DF080}"/>
+              </a:ext>
+            </a:extLst>
+          </p:cNvPr>
+          <p:cNvSpPr>
+            <a:spLocks noGrp="1"/>
+          </p:cNvSpPr>
+          <p:nvPr>
+            <p:ph type="dt" sz="half" idx="10"/>
+          </p:nvPr>
+        </p:nvSpPr>
+        <p:spPr/>
+        <p:txBody>
+          <a:bodyPr/>
+          <a:lstStyle/>
+          <a:p>
+            <a:r>
+              <a:rPr lang="en-US"/>
+              <a:t>22/01/2026</a:t>
+            </a:r>
+          </a:p>
+        </p:txBody>
+      </p:sp>
+      <p:sp>
+        <p:nvSpPr>
+          <p:cNvPr id="4" name="Footer Placeholder 3">
+            <a:extLst>
+              <a:ext uri="{FF2B5EF4-FFF2-40B4-BE49-F238E27FC236}">
+                <a16:creationId xmlns:a16="http://schemas.microsoft.com/office/drawing/2014/main" id="{0B563AFE-7698-93F1-2F6B-61045698AA4D}"/>
+              </a:ext>
+            </a:extLst>
+          </p:cNvPr>
+          <p:cNvSpPr>
+            <a:spLocks noGrp="1"/>
+          </p:cNvSpPr>
+          <p:nvPr>
+            <p:ph type="ftr" sz="quarter" idx="11"/>
+          </p:nvPr>
+        </p:nvSpPr>
+        <p:spPr/>
+        <p:txBody>
+          <a:bodyPr/>
+          <a:lstStyle/>
+          <a:p>
+            <a:r>
+              <a:rPr lang="en-US"/>
+              <a:t>Stefan Cristi Zugravel, elettronica base, TPS lezione 5</a:t>
+            </a:r>
+          </a:p>
+        </p:txBody>
+      </p:sp>
+      <p:sp>
+        <p:nvSpPr>
+          <p:cNvPr id="5" name="Slide Number Placeholder 4">
+            <a:extLst>
+              <a:ext uri="{FF2B5EF4-FFF2-40B4-BE49-F238E27FC236}">
+                <a16:creationId xmlns:a16="http://schemas.microsoft.com/office/drawing/2014/main" id="{153BF318-F50C-019D-342E-B1DF26E00345}"/>
+              </a:ext>
+            </a:extLst>
+          </p:cNvPr>
+          <p:cNvSpPr>
+            <a:spLocks noGrp="1"/>
+          </p:cNvSpPr>
+          <p:nvPr>
+            <p:ph type="sldNum" sz="quarter" idx="12"/>
+          </p:nvPr>
+        </p:nvSpPr>
+        <p:spPr/>
+        <p:txBody>
+          <a:bodyPr/>
+          <a:lstStyle/>
+          <a:p>
+            <a:fld id="{B7C12E76-5DE4-834B-BE10-AD31AA7B20EC}" type="slidenum">
+              <a:rPr lang="en-US" smtClean="0"/>
+              <a:t>18</a:t>
+            </a:fld>
+            <a:endParaRPr lang="en-US"/>
+          </a:p>
+        </p:txBody>
+      </p:sp>
+      <p:pic>
+        <p:nvPicPr>
+          <p:cNvPr id="7" name="Picture 6" descr="A screenshot of a computer code&#10;&#10;AI-generated content may be incorrect.">
+            <a:extLst>
+              <a:ext uri="{FF2B5EF4-FFF2-40B4-BE49-F238E27FC236}">
+                <a16:creationId xmlns:a16="http://schemas.microsoft.com/office/drawing/2014/main" id="{3E325330-2016-D4D0-03AD-1C049BAED332}"/>
+              </a:ext>
+            </a:extLst>
+          </p:cNvPr>
+          <p:cNvPicPr>
+            <a:picLocks noChangeAspect="1"/>
+          </p:cNvPicPr>
+          <p:nvPr/>
+        </p:nvPicPr>
+        <p:blipFill>
+          <a:blip r:embed="rId2"/>
+          <a:stretch>
+            <a:fillRect/>
+          </a:stretch>
+        </p:blipFill>
+        <p:spPr>
+          <a:xfrm>
+            <a:off x="0" y="1675443"/>
+            <a:ext cx="7772400" cy="2235784"/>
+          </a:xfrm>
+          <a:prstGeom prst="rect">
+            <a:avLst/>
+          </a:prstGeom>
+        </p:spPr>
+      </p:pic>
+    </p:spTree>
+    <p:extLst>
+      <p:ext uri="{BB962C8B-B14F-4D97-AF65-F5344CB8AC3E}">
+        <p14:creationId xmlns:p14="http://schemas.microsoft.com/office/powerpoint/2010/main" val="3910830976"/>
+      </p:ext>
+    </p:extLst>
+  </p:cSld>
+  <p:clrMapOvr>
+    <a:masterClrMapping/>
+  </p:clrMapOvr>
+</p:sld>
+</file>
+
+<file path=ppt/slides/slide19.xml><?xml version="1.0" encoding="utf-8"?>
+<p:sld xmlns:a="http://schemas.openxmlformats.org/drawingml/2006/main" xmlns:r="http://schemas.openxmlformats.org/officeDocument/2006/relationships" xmlns:p="http://schemas.openxmlformats.org/presentationml/2006/main">
+  <p:cSld>
+    <p:spTree>
+      <p:nvGrpSpPr>
+        <p:cNvPr id="1" name="">
+          <a:extLst>
+            <a:ext uri="{FF2B5EF4-FFF2-40B4-BE49-F238E27FC236}">
+              <a16:creationId xmlns:a16="http://schemas.microsoft.com/office/drawing/2014/main" id="{197588B2-9F27-EAEB-5C0A-ADA3B39626FD}"/>
+            </a:ext>
+          </a:extLst>
+        </p:cNvPr>
+        <p:cNvGrpSpPr/>
+        <p:nvPr/>
+      </p:nvGrpSpPr>
+      <p:grpSpPr>
+        <a:xfrm>
+          <a:off x="0" y="0"/>
+          <a:ext cx="0" cy="0"/>
+          <a:chOff x="0" y="0"/>
+          <a:chExt cx="0" cy="0"/>
+        </a:xfrm>
+      </p:grpSpPr>
+      <p:sp>
+        <p:nvSpPr>
+          <p:cNvPr id="2" name="Title 1">
+            <a:extLst>
+              <a:ext uri="{FF2B5EF4-FFF2-40B4-BE49-F238E27FC236}">
+                <a16:creationId xmlns:a16="http://schemas.microsoft.com/office/drawing/2014/main" id="{8DCE5C9A-3455-DE2A-0238-63212116A54F}"/>
+              </a:ext>
+            </a:extLst>
+          </p:cNvPr>
+          <p:cNvSpPr>
+            <a:spLocks noGrp="1"/>
+          </p:cNvSpPr>
+          <p:nvPr>
+            <p:ph type="title"/>
+          </p:nvPr>
+        </p:nvSpPr>
+        <p:spPr>
+          <a:xfrm>
+            <a:off x="152397" y="136525"/>
+            <a:ext cx="11861805" cy="1835710"/>
+          </a:xfrm>
+        </p:spPr>
+        <p:txBody>
+          <a:bodyPr anchor="t">
+            <a:normAutofit/>
+          </a:bodyPr>
+          <a:lstStyle/>
+          <a:p>
+            <a:r>
+              <a:rPr lang="en-US" dirty="0"/>
+              <a:t>Lab 8</a:t>
+            </a:r>
+            <a:br>
+              <a:rPr lang="en-US" dirty="0"/>
+            </a:br>
+            <a:r>
+              <a:rPr lang="en-US" dirty="0"/>
+              <a:t>FPGA PWM controller used for LED breathing effect</a:t>
+            </a:r>
+          </a:p>
+        </p:txBody>
+      </p:sp>
+      <p:sp>
+        <p:nvSpPr>
+          <p:cNvPr id="3" name="Date Placeholder 2">
+            <a:extLst>
+              <a:ext uri="{FF2B5EF4-FFF2-40B4-BE49-F238E27FC236}">
+                <a16:creationId xmlns:a16="http://schemas.microsoft.com/office/drawing/2014/main" id="{8AAE7CC9-6094-F83E-D53F-1B882E41060B}"/>
+              </a:ext>
+            </a:extLst>
+          </p:cNvPr>
+          <p:cNvSpPr>
+            <a:spLocks noGrp="1"/>
+          </p:cNvSpPr>
+          <p:nvPr>
+            <p:ph type="dt" sz="half" idx="10"/>
+          </p:nvPr>
+        </p:nvSpPr>
+        <p:spPr/>
+        <p:txBody>
+          <a:bodyPr/>
+          <a:lstStyle/>
+          <a:p>
+            <a:r>
+              <a:rPr lang="en-US"/>
+              <a:t>22/01/2026</a:t>
+            </a:r>
+          </a:p>
+        </p:txBody>
+      </p:sp>
+      <p:sp>
+        <p:nvSpPr>
+          <p:cNvPr id="4" name="Footer Placeholder 3">
+            <a:extLst>
+              <a:ext uri="{FF2B5EF4-FFF2-40B4-BE49-F238E27FC236}">
+                <a16:creationId xmlns:a16="http://schemas.microsoft.com/office/drawing/2014/main" id="{F797D41B-2DF8-24E4-80EB-10F856AE6B7A}"/>
+              </a:ext>
+            </a:extLst>
+          </p:cNvPr>
+          <p:cNvSpPr>
+            <a:spLocks noGrp="1"/>
+          </p:cNvSpPr>
+          <p:nvPr>
+            <p:ph type="ftr" sz="quarter" idx="11"/>
+          </p:nvPr>
+        </p:nvSpPr>
+        <p:spPr/>
+        <p:txBody>
+          <a:bodyPr/>
+          <a:lstStyle/>
+          <a:p>
+            <a:r>
+              <a:rPr lang="en-US"/>
+              <a:t>Stefan Cristi Zugravel, elettronica base, TPS lezione 5</a:t>
+            </a:r>
+          </a:p>
+        </p:txBody>
+      </p:sp>
+      <p:sp>
+        <p:nvSpPr>
+          <p:cNvPr id="5" name="Slide Number Placeholder 4">
+            <a:extLst>
+              <a:ext uri="{FF2B5EF4-FFF2-40B4-BE49-F238E27FC236}">
+                <a16:creationId xmlns:a16="http://schemas.microsoft.com/office/drawing/2014/main" id="{EA689F11-DFE4-3DB7-D4B9-70617C2736B1}"/>
+              </a:ext>
+            </a:extLst>
+          </p:cNvPr>
+          <p:cNvSpPr>
+            <a:spLocks noGrp="1"/>
+          </p:cNvSpPr>
+          <p:nvPr>
+            <p:ph type="sldNum" sz="quarter" idx="12"/>
+          </p:nvPr>
+        </p:nvSpPr>
+        <p:spPr/>
+        <p:txBody>
+          <a:bodyPr/>
+          <a:lstStyle/>
+          <a:p>
+            <a:fld id="{B7C12E76-5DE4-834B-BE10-AD31AA7B20EC}" type="slidenum">
+              <a:rPr lang="en-US" smtClean="0"/>
+              <a:t>19</a:t>
+            </a:fld>
+            <a:endParaRPr lang="en-US"/>
+          </a:p>
+        </p:txBody>
+      </p:sp>
+    </p:spTree>
+    <p:extLst>
+      <p:ext uri="{BB962C8B-B14F-4D97-AF65-F5344CB8AC3E}">
+        <p14:creationId xmlns:p14="http://schemas.microsoft.com/office/powerpoint/2010/main" val="2731775299"/>
       </p:ext>
     </p:extLst>
   </p:cSld>
@@ -3912,12 +5675,34 @@
             <p:ph type="title"/>
           </p:nvPr>
         </p:nvSpPr>
-        <p:spPr/>
-        <p:txBody>
-          <a:bodyPr/>
-          <a:lstStyle/>
-          <a:p>
-            <a:endParaRPr lang="en-US"/>
+        <p:spPr>
+          <a:xfrm>
+            <a:off x="152397" y="136526"/>
+            <a:ext cx="11861805" cy="1692274"/>
+          </a:xfrm>
+        </p:spPr>
+        <p:txBody>
+          <a:bodyPr anchor="t">
+            <a:normAutofit/>
+          </a:bodyPr>
+          <a:lstStyle/>
+          <a:p>
+            <a:r>
+              <a:rPr lang="en-US" dirty="0"/>
+              <a:t>Lab 0</a:t>
+            </a:r>
+            <a:br>
+              <a:rPr lang="en-US" dirty="0"/>
+            </a:br>
+            <a:r>
+              <a:rPr lang="en-US" dirty="0"/>
+              <a:t>Keypad PCB with </a:t>
+            </a:r>
+            <a:r>
+              <a:rPr lang="en-US" dirty="0" err="1"/>
+              <a:t>KiCAD</a:t>
+            </a:r>
+            <a:endParaRPr lang="en-US" dirty="0"/>
           </a:p>
         </p:txBody>
       </p:sp>
@@ -4010,6 +5795,796 @@
     <p:extLst>
       <p:ext uri="{BB962C8B-B14F-4D97-AF65-F5344CB8AC3E}">
         <p14:creationId xmlns:p14="http://schemas.microsoft.com/office/powerpoint/2010/main" val="1667819663"/>
+      </p:ext>
+    </p:extLst>
+  </p:cSld>
+  <p:clrMapOvr>
+    <a:masterClrMapping/>
+  </p:clrMapOvr>
+</p:sld>
+</file>
+
+<file path=ppt/slides/slide20.xml><?xml version="1.0" encoding="utf-8"?>
+<p:sld xmlns:a="http://schemas.openxmlformats.org/drawingml/2006/main" xmlns:r="http://schemas.openxmlformats.org/officeDocument/2006/relationships" xmlns:p="http://schemas.openxmlformats.org/presentationml/2006/main">
+  <p:cSld>
+    <p:spTree>
+      <p:nvGrpSpPr>
+        <p:cNvPr id="1" name=""/>
+        <p:cNvGrpSpPr/>
+        <p:nvPr/>
+      </p:nvGrpSpPr>
+      <p:grpSpPr>
+        <a:xfrm>
+          <a:off x="0" y="0"/>
+          <a:ext cx="0" cy="0"/>
+          <a:chOff x="0" y="0"/>
+          <a:chExt cx="0" cy="0"/>
+        </a:xfrm>
+      </p:grpSpPr>
+      <p:sp>
+        <p:nvSpPr>
+          <p:cNvPr id="2" name="Title 1">
+            <a:extLst>
+              <a:ext uri="{FF2B5EF4-FFF2-40B4-BE49-F238E27FC236}">
+                <a16:creationId xmlns:a16="http://schemas.microsoft.com/office/drawing/2014/main" id="{3C83831D-7EE9-8F96-3CC0-17CE864BCE42}"/>
+              </a:ext>
+            </a:extLst>
+          </p:cNvPr>
+          <p:cNvSpPr>
+            <a:spLocks noGrp="1"/>
+          </p:cNvSpPr>
+          <p:nvPr>
+            <p:ph type="title"/>
+          </p:nvPr>
+        </p:nvSpPr>
+        <p:spPr/>
+        <p:txBody>
+          <a:bodyPr/>
+          <a:lstStyle/>
+          <a:p>
+            <a:endParaRPr lang="en-US"/>
+          </a:p>
+        </p:txBody>
+      </p:sp>
+      <p:sp>
+        <p:nvSpPr>
+          <p:cNvPr id="3" name="Date Placeholder 2">
+            <a:extLst>
+              <a:ext uri="{FF2B5EF4-FFF2-40B4-BE49-F238E27FC236}">
+                <a16:creationId xmlns:a16="http://schemas.microsoft.com/office/drawing/2014/main" id="{6DCC5E95-781C-B4A1-9DA1-D41D71CA37DD}"/>
+              </a:ext>
+            </a:extLst>
+          </p:cNvPr>
+          <p:cNvSpPr>
+            <a:spLocks noGrp="1"/>
+          </p:cNvSpPr>
+          <p:nvPr>
+            <p:ph type="dt" sz="half" idx="10"/>
+          </p:nvPr>
+        </p:nvSpPr>
+        <p:spPr/>
+        <p:txBody>
+          <a:bodyPr/>
+          <a:lstStyle/>
+          <a:p>
+            <a:r>
+              <a:rPr lang="en-US"/>
+              <a:t>22/01/2026</a:t>
+            </a:r>
+          </a:p>
+        </p:txBody>
+      </p:sp>
+      <p:sp>
+        <p:nvSpPr>
+          <p:cNvPr id="4" name="Footer Placeholder 3">
+            <a:extLst>
+              <a:ext uri="{FF2B5EF4-FFF2-40B4-BE49-F238E27FC236}">
+                <a16:creationId xmlns:a16="http://schemas.microsoft.com/office/drawing/2014/main" id="{54DB06FD-DC42-2A37-C456-38F5D4C87773}"/>
+              </a:ext>
+            </a:extLst>
+          </p:cNvPr>
+          <p:cNvSpPr>
+            <a:spLocks noGrp="1"/>
+          </p:cNvSpPr>
+          <p:nvPr>
+            <p:ph type="ftr" sz="quarter" idx="11"/>
+          </p:nvPr>
+        </p:nvSpPr>
+        <p:spPr/>
+        <p:txBody>
+          <a:bodyPr/>
+          <a:lstStyle/>
+          <a:p>
+            <a:r>
+              <a:rPr lang="en-US"/>
+              <a:t>Stefan Cristi Zugravel, elettronica base, TPS lezione 5</a:t>
+            </a:r>
+          </a:p>
+        </p:txBody>
+      </p:sp>
+      <p:sp>
+        <p:nvSpPr>
+          <p:cNvPr id="5" name="Slide Number Placeholder 4">
+            <a:extLst>
+              <a:ext uri="{FF2B5EF4-FFF2-40B4-BE49-F238E27FC236}">
+                <a16:creationId xmlns:a16="http://schemas.microsoft.com/office/drawing/2014/main" id="{78582F3B-1E6B-9D88-A8AA-5BABEC4E691E}"/>
+              </a:ext>
+            </a:extLst>
+          </p:cNvPr>
+          <p:cNvSpPr>
+            <a:spLocks noGrp="1"/>
+          </p:cNvSpPr>
+          <p:nvPr>
+            <p:ph type="sldNum" sz="quarter" idx="12"/>
+          </p:nvPr>
+        </p:nvSpPr>
+        <p:spPr/>
+        <p:txBody>
+          <a:bodyPr/>
+          <a:lstStyle/>
+          <a:p>
+            <a:fld id="{B7C12E76-5DE4-834B-BE10-AD31AA7B20EC}" type="slidenum">
+              <a:rPr lang="en-US" smtClean="0"/>
+              <a:t>20</a:t>
+            </a:fld>
+            <a:endParaRPr lang="en-US"/>
+          </a:p>
+        </p:txBody>
+      </p:sp>
+      <p:pic>
+        <p:nvPicPr>
+          <p:cNvPr id="7" name="Picture 6" descr="A diagram of a circuit&#10;&#10;AI-generated content may be incorrect.">
+            <a:extLst>
+              <a:ext uri="{FF2B5EF4-FFF2-40B4-BE49-F238E27FC236}">
+                <a16:creationId xmlns:a16="http://schemas.microsoft.com/office/drawing/2014/main" id="{E8990ECC-F06E-65DC-7AD0-75F31E954D06}"/>
+              </a:ext>
+            </a:extLst>
+          </p:cNvPr>
+          <p:cNvPicPr>
+            <a:picLocks noChangeAspect="1"/>
+          </p:cNvPicPr>
+          <p:nvPr/>
+        </p:nvPicPr>
+        <p:blipFill>
+          <a:blip r:embed="rId2"/>
+          <a:stretch>
+            <a:fillRect/>
+          </a:stretch>
+        </p:blipFill>
+        <p:spPr>
+          <a:xfrm>
+            <a:off x="224118" y="1812979"/>
+            <a:ext cx="4186521" cy="3924432"/>
+          </a:xfrm>
+          <a:prstGeom prst="rect">
+            <a:avLst/>
+          </a:prstGeom>
+        </p:spPr>
+      </p:pic>
+      <p:pic>
+        <p:nvPicPr>
+          <p:cNvPr id="9" name="Picture 8" descr="A diagram of a power curve&#10;&#10;AI-generated content may be incorrect.">
+            <a:extLst>
+              <a:ext uri="{FF2B5EF4-FFF2-40B4-BE49-F238E27FC236}">
+                <a16:creationId xmlns:a16="http://schemas.microsoft.com/office/drawing/2014/main" id="{141B7946-17EB-42A4-EA67-3376E39BBDEB}"/>
+              </a:ext>
+            </a:extLst>
+          </p:cNvPr>
+          <p:cNvPicPr>
+            <a:picLocks noChangeAspect="1"/>
+          </p:cNvPicPr>
+          <p:nvPr/>
+        </p:nvPicPr>
+        <p:blipFill>
+          <a:blip r:embed="rId3"/>
+          <a:stretch>
+            <a:fillRect/>
+          </a:stretch>
+        </p:blipFill>
+        <p:spPr>
+          <a:xfrm>
+            <a:off x="4267200" y="2025169"/>
+            <a:ext cx="7772400" cy="3491345"/>
+          </a:xfrm>
+          <a:prstGeom prst="rect">
+            <a:avLst/>
+          </a:prstGeom>
+        </p:spPr>
+      </p:pic>
+    </p:spTree>
+    <p:extLst>
+      <p:ext uri="{BB962C8B-B14F-4D97-AF65-F5344CB8AC3E}">
+        <p14:creationId xmlns:p14="http://schemas.microsoft.com/office/powerpoint/2010/main" val="3696810819"/>
+      </p:ext>
+    </p:extLst>
+  </p:cSld>
+  <p:clrMapOvr>
+    <a:masterClrMapping/>
+  </p:clrMapOvr>
+</p:sld>
+</file>
+
+<file path=ppt/slides/slide21.xml><?xml version="1.0" encoding="utf-8"?>
+<p:sld xmlns:a="http://schemas.openxmlformats.org/drawingml/2006/main" xmlns:r="http://schemas.openxmlformats.org/officeDocument/2006/relationships" xmlns:p="http://schemas.openxmlformats.org/presentationml/2006/main">
+  <p:cSld>
+    <p:spTree>
+      <p:nvGrpSpPr>
+        <p:cNvPr id="1" name=""/>
+        <p:cNvGrpSpPr/>
+        <p:nvPr/>
+      </p:nvGrpSpPr>
+      <p:grpSpPr>
+        <a:xfrm>
+          <a:off x="0" y="0"/>
+          <a:ext cx="0" cy="0"/>
+          <a:chOff x="0" y="0"/>
+          <a:chExt cx="0" cy="0"/>
+        </a:xfrm>
+      </p:grpSpPr>
+      <p:sp>
+        <p:nvSpPr>
+          <p:cNvPr id="2" name="Title 1">
+            <a:extLst>
+              <a:ext uri="{FF2B5EF4-FFF2-40B4-BE49-F238E27FC236}">
+                <a16:creationId xmlns:a16="http://schemas.microsoft.com/office/drawing/2014/main" id="{2AA1E47E-C9F1-4473-EF3A-12ACF17608D7}"/>
+              </a:ext>
+            </a:extLst>
+          </p:cNvPr>
+          <p:cNvSpPr>
+            <a:spLocks noGrp="1"/>
+          </p:cNvSpPr>
+          <p:nvPr>
+            <p:ph type="title"/>
+          </p:nvPr>
+        </p:nvSpPr>
+        <p:spPr/>
+        <p:txBody>
+          <a:bodyPr/>
+          <a:lstStyle/>
+          <a:p>
+            <a:endParaRPr lang="en-US" dirty="0"/>
+          </a:p>
+        </p:txBody>
+      </p:sp>
+      <p:sp>
+        <p:nvSpPr>
+          <p:cNvPr id="3" name="Date Placeholder 2">
+            <a:extLst>
+              <a:ext uri="{FF2B5EF4-FFF2-40B4-BE49-F238E27FC236}">
+                <a16:creationId xmlns:a16="http://schemas.microsoft.com/office/drawing/2014/main" id="{EB86BCD4-44AE-0281-1B1D-72B9CD78192C}"/>
+              </a:ext>
+            </a:extLst>
+          </p:cNvPr>
+          <p:cNvSpPr>
+            <a:spLocks noGrp="1"/>
+          </p:cNvSpPr>
+          <p:nvPr>
+            <p:ph type="dt" sz="half" idx="10"/>
+          </p:nvPr>
+        </p:nvSpPr>
+        <p:spPr/>
+        <p:txBody>
+          <a:bodyPr/>
+          <a:lstStyle/>
+          <a:p>
+            <a:r>
+              <a:rPr lang="en-US"/>
+              <a:t>22/01/2026</a:t>
+            </a:r>
+          </a:p>
+        </p:txBody>
+      </p:sp>
+      <p:sp>
+        <p:nvSpPr>
+          <p:cNvPr id="4" name="Footer Placeholder 3">
+            <a:extLst>
+              <a:ext uri="{FF2B5EF4-FFF2-40B4-BE49-F238E27FC236}">
+                <a16:creationId xmlns:a16="http://schemas.microsoft.com/office/drawing/2014/main" id="{3A3D8BD6-9020-3566-C328-14E09DCF8324}"/>
+              </a:ext>
+            </a:extLst>
+          </p:cNvPr>
+          <p:cNvSpPr>
+            <a:spLocks noGrp="1"/>
+          </p:cNvSpPr>
+          <p:nvPr>
+            <p:ph type="ftr" sz="quarter" idx="11"/>
+          </p:nvPr>
+        </p:nvSpPr>
+        <p:spPr/>
+        <p:txBody>
+          <a:bodyPr/>
+          <a:lstStyle/>
+          <a:p>
+            <a:r>
+              <a:rPr lang="en-US"/>
+              <a:t>Stefan Cristi Zugravel, elettronica base, TPS lezione 5</a:t>
+            </a:r>
+          </a:p>
+        </p:txBody>
+      </p:sp>
+      <p:sp>
+        <p:nvSpPr>
+          <p:cNvPr id="5" name="Slide Number Placeholder 4">
+            <a:extLst>
+              <a:ext uri="{FF2B5EF4-FFF2-40B4-BE49-F238E27FC236}">
+                <a16:creationId xmlns:a16="http://schemas.microsoft.com/office/drawing/2014/main" id="{1B8AD1A5-F549-1C27-91F8-0EDD5C616AA2}"/>
+              </a:ext>
+            </a:extLst>
+          </p:cNvPr>
+          <p:cNvSpPr>
+            <a:spLocks noGrp="1"/>
+          </p:cNvSpPr>
+          <p:nvPr>
+            <p:ph type="sldNum" sz="quarter" idx="12"/>
+          </p:nvPr>
+        </p:nvSpPr>
+        <p:spPr/>
+        <p:txBody>
+          <a:bodyPr/>
+          <a:lstStyle/>
+          <a:p>
+            <a:fld id="{B7C12E76-5DE4-834B-BE10-AD31AA7B20EC}" type="slidenum">
+              <a:rPr lang="en-US" smtClean="0"/>
+              <a:t>21</a:t>
+            </a:fld>
+            <a:endParaRPr lang="en-US"/>
+          </a:p>
+        </p:txBody>
+      </p:sp>
+      <p:pic>
+        <p:nvPicPr>
+          <p:cNvPr id="7" name="Picture 6" descr="A diagram of a diagram of a cycle&#10;&#10;AI-generated content may be incorrect.">
+            <a:extLst>
+              <a:ext uri="{FF2B5EF4-FFF2-40B4-BE49-F238E27FC236}">
+                <a16:creationId xmlns:a16="http://schemas.microsoft.com/office/drawing/2014/main" id="{9B12CA96-DE4C-7CC2-F16C-6ABAA34BFD92}"/>
+              </a:ext>
+            </a:extLst>
+          </p:cNvPr>
+          <p:cNvPicPr>
+            <a:picLocks noChangeAspect="1"/>
+          </p:cNvPicPr>
+          <p:nvPr/>
+        </p:nvPicPr>
+        <p:blipFill>
+          <a:blip r:embed="rId2"/>
+          <a:stretch>
+            <a:fillRect/>
+          </a:stretch>
+        </p:blipFill>
+        <p:spPr>
+          <a:xfrm>
+            <a:off x="3495861" y="1805457"/>
+            <a:ext cx="5174876" cy="3930769"/>
+          </a:xfrm>
+          <a:prstGeom prst="rect">
+            <a:avLst/>
+          </a:prstGeom>
+        </p:spPr>
+      </p:pic>
+    </p:spTree>
+    <p:extLst>
+      <p:ext uri="{BB962C8B-B14F-4D97-AF65-F5344CB8AC3E}">
+        <p14:creationId xmlns:p14="http://schemas.microsoft.com/office/powerpoint/2010/main" val="2124086413"/>
+      </p:ext>
+    </p:extLst>
+  </p:cSld>
+  <p:clrMapOvr>
+    <a:masterClrMapping/>
+  </p:clrMapOvr>
+</p:sld>
+</file>
+
+<file path=ppt/slides/slide22.xml><?xml version="1.0" encoding="utf-8"?>
+<p:sld xmlns:a="http://schemas.openxmlformats.org/drawingml/2006/main" xmlns:r="http://schemas.openxmlformats.org/officeDocument/2006/relationships" xmlns:p="http://schemas.openxmlformats.org/presentationml/2006/main">
+  <p:cSld>
+    <p:spTree>
+      <p:nvGrpSpPr>
+        <p:cNvPr id="1" name=""/>
+        <p:cNvGrpSpPr/>
+        <p:nvPr/>
+      </p:nvGrpSpPr>
+      <p:grpSpPr>
+        <a:xfrm>
+          <a:off x="0" y="0"/>
+          <a:ext cx="0" cy="0"/>
+          <a:chOff x="0" y="0"/>
+          <a:chExt cx="0" cy="0"/>
+        </a:xfrm>
+      </p:grpSpPr>
+      <p:sp>
+        <p:nvSpPr>
+          <p:cNvPr id="2" name="Title 1">
+            <a:extLst>
+              <a:ext uri="{FF2B5EF4-FFF2-40B4-BE49-F238E27FC236}">
+                <a16:creationId xmlns:a16="http://schemas.microsoft.com/office/drawing/2014/main" id="{D125CC35-D1B5-0DDB-6E74-E4D1DECBBE21}"/>
+              </a:ext>
+            </a:extLst>
+          </p:cNvPr>
+          <p:cNvSpPr>
+            <a:spLocks noGrp="1"/>
+          </p:cNvSpPr>
+          <p:nvPr>
+            <p:ph type="title"/>
+          </p:nvPr>
+        </p:nvSpPr>
+        <p:spPr/>
+        <p:txBody>
+          <a:bodyPr/>
+          <a:lstStyle/>
+          <a:p>
+            <a:endParaRPr lang="en-US"/>
+          </a:p>
+        </p:txBody>
+      </p:sp>
+      <p:sp>
+        <p:nvSpPr>
+          <p:cNvPr id="3" name="Date Placeholder 2">
+            <a:extLst>
+              <a:ext uri="{FF2B5EF4-FFF2-40B4-BE49-F238E27FC236}">
+                <a16:creationId xmlns:a16="http://schemas.microsoft.com/office/drawing/2014/main" id="{653AA82B-873C-BA3A-71EE-25CBED7CD110}"/>
+              </a:ext>
+            </a:extLst>
+          </p:cNvPr>
+          <p:cNvSpPr>
+            <a:spLocks noGrp="1"/>
+          </p:cNvSpPr>
+          <p:nvPr>
+            <p:ph type="dt" sz="half" idx="10"/>
+          </p:nvPr>
+        </p:nvSpPr>
+        <p:spPr/>
+        <p:txBody>
+          <a:bodyPr/>
+          <a:lstStyle/>
+          <a:p>
+            <a:r>
+              <a:rPr lang="en-US"/>
+              <a:t>22/01/2026</a:t>
+            </a:r>
+          </a:p>
+        </p:txBody>
+      </p:sp>
+      <p:sp>
+        <p:nvSpPr>
+          <p:cNvPr id="4" name="Footer Placeholder 3">
+            <a:extLst>
+              <a:ext uri="{FF2B5EF4-FFF2-40B4-BE49-F238E27FC236}">
+                <a16:creationId xmlns:a16="http://schemas.microsoft.com/office/drawing/2014/main" id="{A5307709-A996-F678-8735-0D17F84602AE}"/>
+              </a:ext>
+            </a:extLst>
+          </p:cNvPr>
+          <p:cNvSpPr>
+            <a:spLocks noGrp="1"/>
+          </p:cNvSpPr>
+          <p:nvPr>
+            <p:ph type="ftr" sz="quarter" idx="11"/>
+          </p:nvPr>
+        </p:nvSpPr>
+        <p:spPr/>
+        <p:txBody>
+          <a:bodyPr/>
+          <a:lstStyle/>
+          <a:p>
+            <a:r>
+              <a:rPr lang="en-US"/>
+              <a:t>Stefan Cristi Zugravel, elettronica base, TPS lezione 5</a:t>
+            </a:r>
+          </a:p>
+        </p:txBody>
+      </p:sp>
+      <p:sp>
+        <p:nvSpPr>
+          <p:cNvPr id="5" name="Slide Number Placeholder 4">
+            <a:extLst>
+              <a:ext uri="{FF2B5EF4-FFF2-40B4-BE49-F238E27FC236}">
+                <a16:creationId xmlns:a16="http://schemas.microsoft.com/office/drawing/2014/main" id="{D1EC889A-6888-B49A-51DD-597956B147A5}"/>
+              </a:ext>
+            </a:extLst>
+          </p:cNvPr>
+          <p:cNvSpPr>
+            <a:spLocks noGrp="1"/>
+          </p:cNvSpPr>
+          <p:nvPr>
+            <p:ph type="sldNum" sz="quarter" idx="12"/>
+          </p:nvPr>
+        </p:nvSpPr>
+        <p:spPr/>
+        <p:txBody>
+          <a:bodyPr/>
+          <a:lstStyle/>
+          <a:p>
+            <a:fld id="{B7C12E76-5DE4-834B-BE10-AD31AA7B20EC}" type="slidenum">
+              <a:rPr lang="en-US" smtClean="0"/>
+              <a:t>22</a:t>
+            </a:fld>
+            <a:endParaRPr lang="en-US"/>
+          </a:p>
+        </p:txBody>
+      </p:sp>
+    </p:spTree>
+    <p:extLst>
+      <p:ext uri="{BB962C8B-B14F-4D97-AF65-F5344CB8AC3E}">
+        <p14:creationId xmlns:p14="http://schemas.microsoft.com/office/powerpoint/2010/main" val="2013613908"/>
+      </p:ext>
+    </p:extLst>
+  </p:cSld>
+  <p:clrMapOvr>
+    <a:masterClrMapping/>
+  </p:clrMapOvr>
+</p:sld>
+</file>
+
+<file path=ppt/slides/slide23.xml><?xml version="1.0" encoding="utf-8"?>
+<p:sld xmlns:a="http://schemas.openxmlformats.org/drawingml/2006/main" xmlns:r="http://schemas.openxmlformats.org/officeDocument/2006/relationships" xmlns:p="http://schemas.openxmlformats.org/presentationml/2006/main">
+  <p:cSld>
+    <p:spTree>
+      <p:nvGrpSpPr>
+        <p:cNvPr id="1" name=""/>
+        <p:cNvGrpSpPr/>
+        <p:nvPr/>
+      </p:nvGrpSpPr>
+      <p:grpSpPr>
+        <a:xfrm>
+          <a:off x="0" y="0"/>
+          <a:ext cx="0" cy="0"/>
+          <a:chOff x="0" y="0"/>
+          <a:chExt cx="0" cy="0"/>
+        </a:xfrm>
+      </p:grpSpPr>
+      <p:sp>
+        <p:nvSpPr>
+          <p:cNvPr id="2" name="Title 1">
+            <a:extLst>
+              <a:ext uri="{FF2B5EF4-FFF2-40B4-BE49-F238E27FC236}">
+                <a16:creationId xmlns:a16="http://schemas.microsoft.com/office/drawing/2014/main" id="{2D7D0D09-9360-9E12-1935-0ED34C3F8C36}"/>
+              </a:ext>
+            </a:extLst>
+          </p:cNvPr>
+          <p:cNvSpPr>
+            <a:spLocks noGrp="1"/>
+          </p:cNvSpPr>
+          <p:nvPr>
+            <p:ph type="title"/>
+          </p:nvPr>
+        </p:nvSpPr>
+        <p:spPr/>
+        <p:txBody>
+          <a:bodyPr/>
+          <a:lstStyle/>
+          <a:p>
+            <a:endParaRPr lang="en-US"/>
+          </a:p>
+        </p:txBody>
+      </p:sp>
+      <p:sp>
+        <p:nvSpPr>
+          <p:cNvPr id="3" name="Date Placeholder 2">
+            <a:extLst>
+              <a:ext uri="{FF2B5EF4-FFF2-40B4-BE49-F238E27FC236}">
+                <a16:creationId xmlns:a16="http://schemas.microsoft.com/office/drawing/2014/main" id="{424D4AA3-2805-A55F-2A4D-F6833C987FDF}"/>
+              </a:ext>
+            </a:extLst>
+          </p:cNvPr>
+          <p:cNvSpPr>
+            <a:spLocks noGrp="1"/>
+          </p:cNvSpPr>
+          <p:nvPr>
+            <p:ph type="dt" sz="half" idx="10"/>
+          </p:nvPr>
+        </p:nvSpPr>
+        <p:spPr/>
+        <p:txBody>
+          <a:bodyPr/>
+          <a:lstStyle/>
+          <a:p>
+            <a:r>
+              <a:rPr lang="en-US"/>
+              <a:t>22/01/2026</a:t>
+            </a:r>
+          </a:p>
+        </p:txBody>
+      </p:sp>
+      <p:sp>
+        <p:nvSpPr>
+          <p:cNvPr id="4" name="Footer Placeholder 3">
+            <a:extLst>
+              <a:ext uri="{FF2B5EF4-FFF2-40B4-BE49-F238E27FC236}">
+                <a16:creationId xmlns:a16="http://schemas.microsoft.com/office/drawing/2014/main" id="{4E1E8780-D153-5368-8F48-9762B7DB7479}"/>
+              </a:ext>
+            </a:extLst>
+          </p:cNvPr>
+          <p:cNvSpPr>
+            <a:spLocks noGrp="1"/>
+          </p:cNvSpPr>
+          <p:nvPr>
+            <p:ph type="ftr" sz="quarter" idx="11"/>
+          </p:nvPr>
+        </p:nvSpPr>
+        <p:spPr/>
+        <p:txBody>
+          <a:bodyPr/>
+          <a:lstStyle/>
+          <a:p>
+            <a:r>
+              <a:rPr lang="en-US"/>
+              <a:t>Stefan Cristi Zugravel, elettronica base, TPS lezione 5</a:t>
+            </a:r>
+          </a:p>
+        </p:txBody>
+      </p:sp>
+      <p:sp>
+        <p:nvSpPr>
+          <p:cNvPr id="5" name="Slide Number Placeholder 4">
+            <a:extLst>
+              <a:ext uri="{FF2B5EF4-FFF2-40B4-BE49-F238E27FC236}">
+                <a16:creationId xmlns:a16="http://schemas.microsoft.com/office/drawing/2014/main" id="{1DDDA955-28A5-56E5-673D-9E24662E6B59}"/>
+              </a:ext>
+            </a:extLst>
+          </p:cNvPr>
+          <p:cNvSpPr>
+            <a:spLocks noGrp="1"/>
+          </p:cNvSpPr>
+          <p:nvPr>
+            <p:ph type="sldNum" sz="quarter" idx="12"/>
+          </p:nvPr>
+        </p:nvSpPr>
+        <p:spPr/>
+        <p:txBody>
+          <a:bodyPr/>
+          <a:lstStyle/>
+          <a:p>
+            <a:fld id="{B7C12E76-5DE4-834B-BE10-AD31AA7B20EC}" type="slidenum">
+              <a:rPr lang="en-US" smtClean="0"/>
+              <a:t>23</a:t>
+            </a:fld>
+            <a:endParaRPr lang="en-US"/>
+          </a:p>
+        </p:txBody>
+      </p:sp>
+    </p:spTree>
+    <p:extLst>
+      <p:ext uri="{BB962C8B-B14F-4D97-AF65-F5344CB8AC3E}">
+        <p14:creationId xmlns:p14="http://schemas.microsoft.com/office/powerpoint/2010/main" val="631273426"/>
+      </p:ext>
+    </p:extLst>
+  </p:cSld>
+  <p:clrMapOvr>
+    <a:masterClrMapping/>
+  </p:clrMapOvr>
+</p:sld>
+</file>
+
+<file path=ppt/slides/slide24.xml><?xml version="1.0" encoding="utf-8"?>
+<p:sld xmlns:a="http://schemas.openxmlformats.org/drawingml/2006/main" xmlns:r="http://schemas.openxmlformats.org/officeDocument/2006/relationships" xmlns:p="http://schemas.openxmlformats.org/presentationml/2006/main">
+  <p:cSld>
+    <p:spTree>
+      <p:nvGrpSpPr>
+        <p:cNvPr id="1" name=""/>
+        <p:cNvGrpSpPr/>
+        <p:nvPr/>
+      </p:nvGrpSpPr>
+      <p:grpSpPr>
+        <a:xfrm>
+          <a:off x="0" y="0"/>
+          <a:ext cx="0" cy="0"/>
+          <a:chOff x="0" y="0"/>
+          <a:chExt cx="0" cy="0"/>
+        </a:xfrm>
+      </p:grpSpPr>
+      <p:sp>
+        <p:nvSpPr>
+          <p:cNvPr id="2" name="Title 1">
+            <a:extLst>
+              <a:ext uri="{FF2B5EF4-FFF2-40B4-BE49-F238E27FC236}">
+                <a16:creationId xmlns:a16="http://schemas.microsoft.com/office/drawing/2014/main" id="{CDB68023-AF5A-4E6D-4418-750D164001F5}"/>
+              </a:ext>
+            </a:extLst>
+          </p:cNvPr>
+          <p:cNvSpPr>
+            <a:spLocks noGrp="1"/>
+          </p:cNvSpPr>
+          <p:nvPr>
+            <p:ph type="title"/>
+          </p:nvPr>
+        </p:nvSpPr>
+        <p:spPr/>
+        <p:txBody>
+          <a:bodyPr/>
+          <a:lstStyle/>
+          <a:p>
+            <a:endParaRPr lang="en-US"/>
+          </a:p>
+        </p:txBody>
+      </p:sp>
+      <p:sp>
+        <p:nvSpPr>
+          <p:cNvPr id="3" name="Date Placeholder 2">
+            <a:extLst>
+              <a:ext uri="{FF2B5EF4-FFF2-40B4-BE49-F238E27FC236}">
+                <a16:creationId xmlns:a16="http://schemas.microsoft.com/office/drawing/2014/main" id="{6199AF3E-D271-0D0E-8F8F-AC42B117CCF0}"/>
+              </a:ext>
+            </a:extLst>
+          </p:cNvPr>
+          <p:cNvSpPr>
+            <a:spLocks noGrp="1"/>
+          </p:cNvSpPr>
+          <p:nvPr>
+            <p:ph type="dt" sz="half" idx="10"/>
+          </p:nvPr>
+        </p:nvSpPr>
+        <p:spPr/>
+        <p:txBody>
+          <a:bodyPr/>
+          <a:lstStyle/>
+          <a:p>
+            <a:r>
+              <a:rPr lang="en-US"/>
+              <a:t>22/01/2026</a:t>
+            </a:r>
+          </a:p>
+        </p:txBody>
+      </p:sp>
+      <p:sp>
+        <p:nvSpPr>
+          <p:cNvPr id="4" name="Footer Placeholder 3">
+            <a:extLst>
+              <a:ext uri="{FF2B5EF4-FFF2-40B4-BE49-F238E27FC236}">
+                <a16:creationId xmlns:a16="http://schemas.microsoft.com/office/drawing/2014/main" id="{1E675BE5-0B0D-BB52-FF35-4693413BB2E7}"/>
+              </a:ext>
+            </a:extLst>
+          </p:cNvPr>
+          <p:cNvSpPr>
+            <a:spLocks noGrp="1"/>
+          </p:cNvSpPr>
+          <p:nvPr>
+            <p:ph type="ftr" sz="quarter" idx="11"/>
+          </p:nvPr>
+        </p:nvSpPr>
+        <p:spPr/>
+        <p:txBody>
+          <a:bodyPr/>
+          <a:lstStyle/>
+          <a:p>
+            <a:r>
+              <a:rPr lang="en-US"/>
+              <a:t>Stefan Cristi Zugravel, elettronica base, TPS lezione 5</a:t>
+            </a:r>
+          </a:p>
+        </p:txBody>
+      </p:sp>
+      <p:sp>
+        <p:nvSpPr>
+          <p:cNvPr id="5" name="Slide Number Placeholder 4">
+            <a:extLst>
+              <a:ext uri="{FF2B5EF4-FFF2-40B4-BE49-F238E27FC236}">
+                <a16:creationId xmlns:a16="http://schemas.microsoft.com/office/drawing/2014/main" id="{4E042B2F-FDB6-AF53-7B37-5DD5F6FC5F92}"/>
+              </a:ext>
+            </a:extLst>
+          </p:cNvPr>
+          <p:cNvSpPr>
+            <a:spLocks noGrp="1"/>
+          </p:cNvSpPr>
+          <p:nvPr>
+            <p:ph type="sldNum" sz="quarter" idx="12"/>
+          </p:nvPr>
+        </p:nvSpPr>
+        <p:spPr/>
+        <p:txBody>
+          <a:bodyPr/>
+          <a:lstStyle/>
+          <a:p>
+            <a:fld id="{B7C12E76-5DE4-834B-BE10-AD31AA7B20EC}" type="slidenum">
+              <a:rPr lang="en-US" smtClean="0"/>
+              <a:t>24</a:t>
+            </a:fld>
+            <a:endParaRPr lang="en-US"/>
+          </a:p>
+        </p:txBody>
+      </p:sp>
+    </p:spTree>
+    <p:extLst>
+      <p:ext uri="{BB962C8B-B14F-4D97-AF65-F5344CB8AC3E}">
+        <p14:creationId xmlns:p14="http://schemas.microsoft.com/office/powerpoint/2010/main" val="2961610399"/>
       </p:ext>
     </p:extLst>
   </p:cSld>
@@ -4041,7 +6616,7 @@
           <p:cNvPr id="2" name="Title 1">
             <a:extLst>
               <a:ext uri="{FF2B5EF4-FFF2-40B4-BE49-F238E27FC236}">
-                <a16:creationId xmlns:a16="http://schemas.microsoft.com/office/drawing/2014/main" id="{3C83831D-7EE9-8F96-3CC0-17CE864BCE42}"/>
+                <a16:creationId xmlns:a16="http://schemas.microsoft.com/office/drawing/2014/main" id="{E0943474-B60B-1630-8282-DC0AC48D5B6D}"/>
               </a:ext>
             </a:extLst>
           </p:cNvPr>
@@ -4057,7 +6632,10 @@
           <a:bodyPr/>
           <a:lstStyle/>
           <a:p>
-            <a:endParaRPr lang="en-US"/>
+            <a:r>
+              <a:rPr lang="en-US" dirty="0"/>
+              <a:t>Schematic</a:t>
+            </a:r>
           </a:p>
         </p:txBody>
       </p:sp>
@@ -4066,7 +6644,7 @@
           <p:cNvPr id="3" name="Date Placeholder 2">
             <a:extLst>
               <a:ext uri="{FF2B5EF4-FFF2-40B4-BE49-F238E27FC236}">
-                <a16:creationId xmlns:a16="http://schemas.microsoft.com/office/drawing/2014/main" id="{6DCC5E95-781C-B4A1-9DA1-D41D71CA37DD}"/>
+                <a16:creationId xmlns:a16="http://schemas.microsoft.com/office/drawing/2014/main" id="{06973C7E-C716-C29C-055A-C8548C3BDE6E}"/>
               </a:ext>
             </a:extLst>
           </p:cNvPr>
@@ -4094,7 +6672,7 @@
           <p:cNvPr id="4" name="Footer Placeholder 3">
             <a:extLst>
               <a:ext uri="{FF2B5EF4-FFF2-40B4-BE49-F238E27FC236}">
-                <a16:creationId xmlns:a16="http://schemas.microsoft.com/office/drawing/2014/main" id="{54DB06FD-DC42-2A37-C456-38F5D4C87773}"/>
+                <a16:creationId xmlns:a16="http://schemas.microsoft.com/office/drawing/2014/main" id="{4EC45FB2-8DA5-CC55-8DB5-60A2CDF2FDFF}"/>
               </a:ext>
             </a:extLst>
           </p:cNvPr>
@@ -4122,7 +6700,7 @@
           <p:cNvPr id="5" name="Slide Number Placeholder 4">
             <a:extLst>
               <a:ext uri="{FF2B5EF4-FFF2-40B4-BE49-F238E27FC236}">
-                <a16:creationId xmlns:a16="http://schemas.microsoft.com/office/drawing/2014/main" id="{78582F3B-1E6B-9D88-A8AA-5BABEC4E691E}"/>
+                <a16:creationId xmlns:a16="http://schemas.microsoft.com/office/drawing/2014/main" id="{9CC0A99E-5312-1EF3-462A-C5B211D0D046}"/>
               </a:ext>
             </a:extLst>
           </p:cNvPr>
@@ -4146,10 +6724,40 @@
           </a:p>
         </p:txBody>
       </p:sp>
+      <p:pic>
+        <p:nvPicPr>
+          <p:cNvPr id="7" name="Picture 6" descr="A diagram of a circuit board&#10;&#10;AI-generated content may be incorrect.">
+            <a:extLst>
+              <a:ext uri="{FF2B5EF4-FFF2-40B4-BE49-F238E27FC236}">
+                <a16:creationId xmlns:a16="http://schemas.microsoft.com/office/drawing/2014/main" id="{9769027B-8803-1830-FA53-729A944140B1}"/>
+              </a:ext>
+            </a:extLst>
+          </p:cNvPr>
+          <p:cNvPicPr>
+            <a:picLocks noChangeAspect="1"/>
+          </p:cNvPicPr>
+          <p:nvPr/>
+        </p:nvPicPr>
+        <p:blipFill>
+          <a:blip r:embed="rId2"/>
+          <a:stretch>
+            <a:fillRect/>
+          </a:stretch>
+        </p:blipFill>
+        <p:spPr>
+          <a:xfrm>
+            <a:off x="952201" y="1366915"/>
+            <a:ext cx="10262196" cy="4888536"/>
+          </a:xfrm>
+          <a:prstGeom prst="rect">
+            <a:avLst/>
+          </a:prstGeom>
+        </p:spPr>
+      </p:pic>
     </p:spTree>
     <p:extLst>
       <p:ext uri="{BB962C8B-B14F-4D97-AF65-F5344CB8AC3E}">
-        <p14:creationId xmlns:p14="http://schemas.microsoft.com/office/powerpoint/2010/main" val="3696810819"/>
+        <p14:creationId xmlns:p14="http://schemas.microsoft.com/office/powerpoint/2010/main" val="804807677"/>
       </p:ext>
     </p:extLst>
   </p:cSld>
@@ -4181,7 +6789,7 @@
           <p:cNvPr id="2" name="Title 1">
             <a:extLst>
               <a:ext uri="{FF2B5EF4-FFF2-40B4-BE49-F238E27FC236}">
-                <a16:creationId xmlns:a16="http://schemas.microsoft.com/office/drawing/2014/main" id="{2AA1E47E-C9F1-4473-EF3A-12ACF17608D7}"/>
+                <a16:creationId xmlns:a16="http://schemas.microsoft.com/office/drawing/2014/main" id="{6F0F50DB-BA5F-97DC-A4BA-CD149540FF10}"/>
               </a:ext>
             </a:extLst>
           </p:cNvPr>
@@ -4197,7 +6805,10 @@
           <a:bodyPr/>
           <a:lstStyle/>
           <a:p>
-            <a:endParaRPr lang="en-US"/>
+            <a:r>
+              <a:rPr lang="en-US" dirty="0"/>
+              <a:t>Layout</a:t>
+            </a:r>
           </a:p>
         </p:txBody>
       </p:sp>
@@ -4206,7 +6817,7 @@
           <p:cNvPr id="3" name="Date Placeholder 2">
             <a:extLst>
               <a:ext uri="{FF2B5EF4-FFF2-40B4-BE49-F238E27FC236}">
-                <a16:creationId xmlns:a16="http://schemas.microsoft.com/office/drawing/2014/main" id="{EB86BCD4-44AE-0281-1B1D-72B9CD78192C}"/>
+                <a16:creationId xmlns:a16="http://schemas.microsoft.com/office/drawing/2014/main" id="{44A5F840-F489-295F-C084-0E6119E0D11F}"/>
               </a:ext>
             </a:extLst>
           </p:cNvPr>
@@ -4234,7 +6845,7 @@
           <p:cNvPr id="4" name="Footer Placeholder 3">
             <a:extLst>
               <a:ext uri="{FF2B5EF4-FFF2-40B4-BE49-F238E27FC236}">
-                <a16:creationId xmlns:a16="http://schemas.microsoft.com/office/drawing/2014/main" id="{3A3D8BD6-9020-3566-C328-14E09DCF8324}"/>
+                <a16:creationId xmlns:a16="http://schemas.microsoft.com/office/drawing/2014/main" id="{1E49838F-BD71-73B9-E02B-27BE114BC65F}"/>
               </a:ext>
             </a:extLst>
           </p:cNvPr>
@@ -4262,7 +6873,7 @@
           <p:cNvPr id="5" name="Slide Number Placeholder 4">
             <a:extLst>
               <a:ext uri="{FF2B5EF4-FFF2-40B4-BE49-F238E27FC236}">
-                <a16:creationId xmlns:a16="http://schemas.microsoft.com/office/drawing/2014/main" id="{1B8AD1A5-F549-1C27-91F8-0EDD5C616AA2}"/>
+                <a16:creationId xmlns:a16="http://schemas.microsoft.com/office/drawing/2014/main" id="{530CC6C1-3B19-311E-931D-25A91BE367F2}"/>
               </a:ext>
             </a:extLst>
           </p:cNvPr>
@@ -4286,10 +6897,70 @@
           </a:p>
         </p:txBody>
       </p:sp>
+      <p:pic>
+        <p:nvPicPr>
+          <p:cNvPr id="7" name="Picture 6" descr="A computer screen shot of a circuit board&#10;&#10;AI-generated content may be incorrect.">
+            <a:extLst>
+              <a:ext uri="{FF2B5EF4-FFF2-40B4-BE49-F238E27FC236}">
+                <a16:creationId xmlns:a16="http://schemas.microsoft.com/office/drawing/2014/main" id="{30AAF170-F109-3299-DB14-8DEA8C8DE841}"/>
+              </a:ext>
+            </a:extLst>
+          </p:cNvPr>
+          <p:cNvPicPr>
+            <a:picLocks noChangeAspect="1"/>
+          </p:cNvPicPr>
+          <p:nvPr/>
+        </p:nvPicPr>
+        <p:blipFill>
+          <a:blip r:embed="rId2"/>
+          <a:stretch>
+            <a:fillRect/>
+          </a:stretch>
+        </p:blipFill>
+        <p:spPr>
+          <a:xfrm>
+            <a:off x="475806" y="964453"/>
+            <a:ext cx="5248921" cy="4929094"/>
+          </a:xfrm>
+          <a:prstGeom prst="rect">
+            <a:avLst/>
+          </a:prstGeom>
+        </p:spPr>
+      </p:pic>
+      <p:pic>
+        <p:nvPicPr>
+          <p:cNvPr id="9" name="Picture 8" descr="A green circuit board with black and white squares&#10;&#10;AI-generated content may be incorrect.">
+            <a:extLst>
+              <a:ext uri="{FF2B5EF4-FFF2-40B4-BE49-F238E27FC236}">
+                <a16:creationId xmlns:a16="http://schemas.microsoft.com/office/drawing/2014/main" id="{829B3E12-42EF-7D13-7B3C-343392243215}"/>
+              </a:ext>
+            </a:extLst>
+          </p:cNvPr>
+          <p:cNvPicPr>
+            <a:picLocks noChangeAspect="1"/>
+          </p:cNvPicPr>
+          <p:nvPr/>
+        </p:nvPicPr>
+        <p:blipFill>
+          <a:blip r:embed="rId3"/>
+          <a:stretch>
+            <a:fillRect/>
+          </a:stretch>
+        </p:blipFill>
+        <p:spPr>
+          <a:xfrm>
+            <a:off x="6467274" y="967448"/>
+            <a:ext cx="5546928" cy="4929094"/>
+          </a:xfrm>
+          <a:prstGeom prst="rect">
+            <a:avLst/>
+          </a:prstGeom>
+        </p:spPr>
+      </p:pic>
     </p:spTree>
     <p:extLst>
       <p:ext uri="{BB962C8B-B14F-4D97-AF65-F5344CB8AC3E}">
-        <p14:creationId xmlns:p14="http://schemas.microsoft.com/office/powerpoint/2010/main" val="2124086413"/>
+        <p14:creationId xmlns:p14="http://schemas.microsoft.com/office/powerpoint/2010/main" val="2461161680"/>
       </p:ext>
     </p:extLst>
   </p:cSld>
@@ -4304,7 +6975,13 @@
   <p:cSld>
     <p:spTree>
       <p:nvGrpSpPr>
-        <p:cNvPr id="1" name=""/>
+        <p:cNvPr id="1" name="">
+          <a:extLst>
+            <a:ext uri="{FF2B5EF4-FFF2-40B4-BE49-F238E27FC236}">
+              <a16:creationId xmlns:a16="http://schemas.microsoft.com/office/drawing/2014/main" id="{800DE827-21C4-30A7-B02B-AA5DA3831657}"/>
+            </a:ext>
+          </a:extLst>
+        </p:cNvPr>
         <p:cNvGrpSpPr/>
         <p:nvPr/>
       </p:nvGrpSpPr>
@@ -4321,7 +6998,7 @@
           <p:cNvPr id="2" name="Title 1">
             <a:extLst>
               <a:ext uri="{FF2B5EF4-FFF2-40B4-BE49-F238E27FC236}">
-                <a16:creationId xmlns:a16="http://schemas.microsoft.com/office/drawing/2014/main" id="{D125CC35-D1B5-0DDB-6E74-E4D1DECBBE21}"/>
+                <a16:creationId xmlns:a16="http://schemas.microsoft.com/office/drawing/2014/main" id="{5D1C7C8A-77C2-631E-EAEF-BAD4635A0C66}"/>
               </a:ext>
             </a:extLst>
           </p:cNvPr>
@@ -4332,12 +7009,29 @@
             <p:ph type="title"/>
           </p:nvPr>
         </p:nvSpPr>
-        <p:spPr/>
-        <p:txBody>
-          <a:bodyPr/>
-          <a:lstStyle/>
-          <a:p>
-            <a:endParaRPr lang="en-US"/>
+        <p:spPr>
+          <a:xfrm>
+            <a:off x="152397" y="136525"/>
+            <a:ext cx="11861805" cy="2212227"/>
+          </a:xfrm>
+        </p:spPr>
+        <p:txBody>
+          <a:bodyPr anchor="t">
+            <a:normAutofit/>
+          </a:bodyPr>
+          <a:lstStyle/>
+          <a:p>
+            <a:r>
+              <a:rPr lang="en-US" dirty="0"/>
+              <a:t>Lab 1</a:t>
+            </a:r>
+            <a:br>
+              <a:rPr lang="en-US" dirty="0"/>
+            </a:br>
+            <a:r>
+              <a:rPr lang="en-US" dirty="0"/>
+              <a:t>Current sensing PCB</a:t>
+            </a:r>
           </a:p>
         </p:txBody>
       </p:sp>
@@ -4346,7 +7040,7 @@
           <p:cNvPr id="3" name="Date Placeholder 2">
             <a:extLst>
               <a:ext uri="{FF2B5EF4-FFF2-40B4-BE49-F238E27FC236}">
-                <a16:creationId xmlns:a16="http://schemas.microsoft.com/office/drawing/2014/main" id="{653AA82B-873C-BA3A-71EE-25CBED7CD110}"/>
+                <a16:creationId xmlns:a16="http://schemas.microsoft.com/office/drawing/2014/main" id="{3695B82C-9EC8-9AA9-2EB1-19F199EE7E75}"/>
               </a:ext>
             </a:extLst>
           </p:cNvPr>
@@ -4374,7 +7068,7 @@
           <p:cNvPr id="4" name="Footer Placeholder 3">
             <a:extLst>
               <a:ext uri="{FF2B5EF4-FFF2-40B4-BE49-F238E27FC236}">
-                <a16:creationId xmlns:a16="http://schemas.microsoft.com/office/drawing/2014/main" id="{A5307709-A996-F678-8735-0D17F84602AE}"/>
+                <a16:creationId xmlns:a16="http://schemas.microsoft.com/office/drawing/2014/main" id="{0511495C-DE04-867D-0044-DF370A4B9611}"/>
               </a:ext>
             </a:extLst>
           </p:cNvPr>
@@ -4402,7 +7096,7 @@
           <p:cNvPr id="5" name="Slide Number Placeholder 4">
             <a:extLst>
               <a:ext uri="{FF2B5EF4-FFF2-40B4-BE49-F238E27FC236}">
-                <a16:creationId xmlns:a16="http://schemas.microsoft.com/office/drawing/2014/main" id="{D1EC889A-6888-B49A-51DD-597956B147A5}"/>
+                <a16:creationId xmlns:a16="http://schemas.microsoft.com/office/drawing/2014/main" id="{E4B982DD-1C5E-87D0-8928-0C32712A5AF8}"/>
               </a:ext>
             </a:extLst>
           </p:cNvPr>
@@ -4429,7 +7123,7 @@
     </p:spTree>
     <p:extLst>
       <p:ext uri="{BB962C8B-B14F-4D97-AF65-F5344CB8AC3E}">
-        <p14:creationId xmlns:p14="http://schemas.microsoft.com/office/powerpoint/2010/main" val="2013613908"/>
+        <p14:creationId xmlns:p14="http://schemas.microsoft.com/office/powerpoint/2010/main" val="2173826582"/>
       </p:ext>
     </p:extLst>
   </p:cSld>
@@ -4461,7 +7155,7 @@
           <p:cNvPr id="2" name="Title 1">
             <a:extLst>
               <a:ext uri="{FF2B5EF4-FFF2-40B4-BE49-F238E27FC236}">
-                <a16:creationId xmlns:a16="http://schemas.microsoft.com/office/drawing/2014/main" id="{2D7D0D09-9360-9E12-1935-0ED34C3F8C36}"/>
+                <a16:creationId xmlns:a16="http://schemas.microsoft.com/office/drawing/2014/main" id="{3CEB2BB7-92A3-5F4F-E174-6AF577D0F46C}"/>
               </a:ext>
             </a:extLst>
           </p:cNvPr>
@@ -4477,7 +7171,10 @@
           <a:bodyPr/>
           <a:lstStyle/>
           <a:p>
-            <a:endParaRPr lang="en-US"/>
+            <a:r>
+              <a:rPr lang="en-US" dirty="0"/>
+              <a:t>Block Diagram</a:t>
+            </a:r>
           </a:p>
         </p:txBody>
       </p:sp>
@@ -4486,7 +7183,7 @@
           <p:cNvPr id="3" name="Date Placeholder 2">
             <a:extLst>
               <a:ext uri="{FF2B5EF4-FFF2-40B4-BE49-F238E27FC236}">
-                <a16:creationId xmlns:a16="http://schemas.microsoft.com/office/drawing/2014/main" id="{424D4AA3-2805-A55F-2A4D-F6833C987FDF}"/>
+                <a16:creationId xmlns:a16="http://schemas.microsoft.com/office/drawing/2014/main" id="{48928209-C225-0A0E-68F1-C44F16F2A3C6}"/>
               </a:ext>
             </a:extLst>
           </p:cNvPr>
@@ -4514,7 +7211,7 @@
           <p:cNvPr id="4" name="Footer Placeholder 3">
             <a:extLst>
               <a:ext uri="{FF2B5EF4-FFF2-40B4-BE49-F238E27FC236}">
-                <a16:creationId xmlns:a16="http://schemas.microsoft.com/office/drawing/2014/main" id="{4E1E8780-D153-5368-8F48-9762B7DB7479}"/>
+                <a16:creationId xmlns:a16="http://schemas.microsoft.com/office/drawing/2014/main" id="{1D90C4D5-F8AF-2B3D-3190-073A52EB3C15}"/>
               </a:ext>
             </a:extLst>
           </p:cNvPr>
@@ -4542,7 +7239,7 @@
           <p:cNvPr id="5" name="Slide Number Placeholder 4">
             <a:extLst>
               <a:ext uri="{FF2B5EF4-FFF2-40B4-BE49-F238E27FC236}">
-                <a16:creationId xmlns:a16="http://schemas.microsoft.com/office/drawing/2014/main" id="{1DDDA955-28A5-56E5-673D-9E24662E6B59}"/>
+                <a16:creationId xmlns:a16="http://schemas.microsoft.com/office/drawing/2014/main" id="{D1F5BE46-A0F3-BC9D-2B31-F764ADD3BAD2}"/>
               </a:ext>
             </a:extLst>
           </p:cNvPr>
@@ -4566,10 +7263,70 @@
           </a:p>
         </p:txBody>
       </p:sp>
+      <p:pic>
+        <p:nvPicPr>
+          <p:cNvPr id="7" name="Picture 6">
+            <a:extLst>
+              <a:ext uri="{FF2B5EF4-FFF2-40B4-BE49-F238E27FC236}">
+                <a16:creationId xmlns:a16="http://schemas.microsoft.com/office/drawing/2014/main" id="{D3643B52-A104-F46F-9B78-C5C80FDFFCD1}"/>
+              </a:ext>
+            </a:extLst>
+          </p:cNvPr>
+          <p:cNvPicPr>
+            <a:picLocks noChangeAspect="1"/>
+          </p:cNvPicPr>
+          <p:nvPr/>
+        </p:nvPicPr>
+        <p:blipFill>
+          <a:blip r:embed="rId2"/>
+          <a:stretch>
+            <a:fillRect/>
+          </a:stretch>
+        </p:blipFill>
+        <p:spPr>
+          <a:xfrm>
+            <a:off x="527798" y="1420161"/>
+            <a:ext cx="5105146" cy="4222353"/>
+          </a:xfrm>
+          <a:prstGeom prst="rect">
+            <a:avLst/>
+          </a:prstGeom>
+        </p:spPr>
+      </p:pic>
+      <p:pic>
+        <p:nvPicPr>
+          <p:cNvPr id="9" name="Picture 8">
+            <a:extLst>
+              <a:ext uri="{FF2B5EF4-FFF2-40B4-BE49-F238E27FC236}">
+                <a16:creationId xmlns:a16="http://schemas.microsoft.com/office/drawing/2014/main" id="{9D9E1FD2-A2C2-7D5C-1496-DD38E5EA05DB}"/>
+              </a:ext>
+            </a:extLst>
+          </p:cNvPr>
+          <p:cNvPicPr>
+            <a:picLocks noChangeAspect="1"/>
+          </p:cNvPicPr>
+          <p:nvPr/>
+        </p:nvPicPr>
+        <p:blipFill>
+          <a:blip r:embed="rId3"/>
+          <a:stretch>
+            <a:fillRect/>
+          </a:stretch>
+        </p:blipFill>
+        <p:spPr>
+          <a:xfrm>
+            <a:off x="6096000" y="2262190"/>
+            <a:ext cx="5568202" cy="2538297"/>
+          </a:xfrm>
+          <a:prstGeom prst="rect">
+            <a:avLst/>
+          </a:prstGeom>
+        </p:spPr>
+      </p:pic>
     </p:spTree>
     <p:extLst>
       <p:ext uri="{BB962C8B-B14F-4D97-AF65-F5344CB8AC3E}">
-        <p14:creationId xmlns:p14="http://schemas.microsoft.com/office/powerpoint/2010/main" val="631273426"/>
+        <p14:creationId xmlns:p14="http://schemas.microsoft.com/office/powerpoint/2010/main" val="3327517304"/>
       </p:ext>
     </p:extLst>
   </p:cSld>
@@ -4601,7 +7358,7 @@
           <p:cNvPr id="2" name="Title 1">
             <a:extLst>
               <a:ext uri="{FF2B5EF4-FFF2-40B4-BE49-F238E27FC236}">
-                <a16:creationId xmlns:a16="http://schemas.microsoft.com/office/drawing/2014/main" id="{CDB68023-AF5A-4E6D-4418-750D164001F5}"/>
+                <a16:creationId xmlns:a16="http://schemas.microsoft.com/office/drawing/2014/main" id="{563F6671-54FE-E257-E057-0CABEB63920A}"/>
               </a:ext>
             </a:extLst>
           </p:cNvPr>
@@ -4617,7 +7374,10 @@
           <a:bodyPr/>
           <a:lstStyle/>
           <a:p>
-            <a:endParaRPr lang="en-US"/>
+            <a:r>
+              <a:rPr lang="en-US" dirty="0"/>
+              <a:t>Layout and 3D model</a:t>
+            </a:r>
           </a:p>
         </p:txBody>
       </p:sp>
@@ -4626,7 +7386,7 @@
           <p:cNvPr id="3" name="Date Placeholder 2">
             <a:extLst>
               <a:ext uri="{FF2B5EF4-FFF2-40B4-BE49-F238E27FC236}">
-                <a16:creationId xmlns:a16="http://schemas.microsoft.com/office/drawing/2014/main" id="{6199AF3E-D271-0D0E-8F8F-AC42B117CCF0}"/>
+                <a16:creationId xmlns:a16="http://schemas.microsoft.com/office/drawing/2014/main" id="{38CB63E0-DEE2-0804-B061-1F593E28D225}"/>
               </a:ext>
             </a:extLst>
           </p:cNvPr>
@@ -4654,7 +7414,7 @@
           <p:cNvPr id="4" name="Footer Placeholder 3">
             <a:extLst>
               <a:ext uri="{FF2B5EF4-FFF2-40B4-BE49-F238E27FC236}">
-                <a16:creationId xmlns:a16="http://schemas.microsoft.com/office/drawing/2014/main" id="{1E675BE5-0B0D-BB52-FF35-4693413BB2E7}"/>
+                <a16:creationId xmlns:a16="http://schemas.microsoft.com/office/drawing/2014/main" id="{404371E0-AACF-1E80-23B1-8EF939204A95}"/>
               </a:ext>
             </a:extLst>
           </p:cNvPr>
@@ -4682,7 +7442,7 @@
           <p:cNvPr id="5" name="Slide Number Placeholder 4">
             <a:extLst>
               <a:ext uri="{FF2B5EF4-FFF2-40B4-BE49-F238E27FC236}">
-                <a16:creationId xmlns:a16="http://schemas.microsoft.com/office/drawing/2014/main" id="{4E042B2F-FDB6-AF53-7B37-5DD5F6FC5F92}"/>
+                <a16:creationId xmlns:a16="http://schemas.microsoft.com/office/drawing/2014/main" id="{EE8A3FBF-836B-2789-C1C9-5535196B6C7A}"/>
               </a:ext>
             </a:extLst>
           </p:cNvPr>
@@ -4706,10 +7466,396 @@
           </a:p>
         </p:txBody>
       </p:sp>
+      <p:pic>
+        <p:nvPicPr>
+          <p:cNvPr id="7" name="Picture 6" descr="A computer screen shot of a circuit board&#10;&#10;AI-generated content may be incorrect.">
+            <a:extLst>
+              <a:ext uri="{FF2B5EF4-FFF2-40B4-BE49-F238E27FC236}">
+                <a16:creationId xmlns:a16="http://schemas.microsoft.com/office/drawing/2014/main" id="{AFDE34CD-F8C5-12C7-2094-DA9F40D47F46}"/>
+              </a:ext>
+            </a:extLst>
+          </p:cNvPr>
+          <p:cNvPicPr>
+            <a:picLocks noChangeAspect="1"/>
+          </p:cNvPicPr>
+          <p:nvPr/>
+        </p:nvPicPr>
+        <p:blipFill>
+          <a:blip r:embed="rId2"/>
+          <a:stretch>
+            <a:fillRect/>
+          </a:stretch>
+        </p:blipFill>
+        <p:spPr>
+          <a:xfrm>
+            <a:off x="970606" y="1182416"/>
+            <a:ext cx="3849983" cy="5176852"/>
+          </a:xfrm>
+          <a:prstGeom prst="rect">
+            <a:avLst/>
+          </a:prstGeom>
+        </p:spPr>
+      </p:pic>
+      <p:pic>
+        <p:nvPicPr>
+          <p:cNvPr id="9" name="Picture 8" descr="A green circuit board with many green components&#10;&#10;AI-generated content may be incorrect.">
+            <a:extLst>
+              <a:ext uri="{FF2B5EF4-FFF2-40B4-BE49-F238E27FC236}">
+                <a16:creationId xmlns:a16="http://schemas.microsoft.com/office/drawing/2014/main" id="{56CE2F23-0C6A-683C-9EDF-540BC14CCEF5}"/>
+              </a:ext>
+            </a:extLst>
+          </p:cNvPr>
+          <p:cNvPicPr>
+            <a:picLocks noChangeAspect="1"/>
+          </p:cNvPicPr>
+          <p:nvPr/>
+        </p:nvPicPr>
+        <p:blipFill>
+          <a:blip r:embed="rId3"/>
+          <a:stretch>
+            <a:fillRect/>
+          </a:stretch>
+        </p:blipFill>
+        <p:spPr>
+          <a:xfrm>
+            <a:off x="5938192" y="1182416"/>
+            <a:ext cx="5767336" cy="5173934"/>
+          </a:xfrm>
+          <a:prstGeom prst="rect">
+            <a:avLst/>
+          </a:prstGeom>
+        </p:spPr>
+      </p:pic>
     </p:spTree>
     <p:extLst>
       <p:ext uri="{BB962C8B-B14F-4D97-AF65-F5344CB8AC3E}">
-        <p14:creationId xmlns:p14="http://schemas.microsoft.com/office/powerpoint/2010/main" val="2961610399"/>
+        <p14:creationId xmlns:p14="http://schemas.microsoft.com/office/powerpoint/2010/main" val="3841589459"/>
+      </p:ext>
+    </p:extLst>
+  </p:cSld>
+  <p:clrMapOvr>
+    <a:masterClrMapping/>
+  </p:clrMapOvr>
+</p:sld>
+</file>
+
+<file path=ppt/slides/slide8.xml><?xml version="1.0" encoding="utf-8"?>
+<p:sld xmlns:a="http://schemas.openxmlformats.org/drawingml/2006/main" xmlns:r="http://schemas.openxmlformats.org/officeDocument/2006/relationships" xmlns:p="http://schemas.openxmlformats.org/presentationml/2006/main">
+  <p:cSld>
+    <p:spTree>
+      <p:nvGrpSpPr>
+        <p:cNvPr id="1" name="">
+          <a:extLst>
+            <a:ext uri="{FF2B5EF4-FFF2-40B4-BE49-F238E27FC236}">
+              <a16:creationId xmlns:a16="http://schemas.microsoft.com/office/drawing/2014/main" id="{302EF5A8-AE6E-981B-3C14-FA069D0EEC25}"/>
+            </a:ext>
+          </a:extLst>
+        </p:cNvPr>
+        <p:cNvGrpSpPr/>
+        <p:nvPr/>
+      </p:nvGrpSpPr>
+      <p:grpSpPr>
+        <a:xfrm>
+          <a:off x="0" y="0"/>
+          <a:ext cx="0" cy="0"/>
+          <a:chOff x="0" y="0"/>
+          <a:chExt cx="0" cy="0"/>
+        </a:xfrm>
+      </p:grpSpPr>
+      <p:sp>
+        <p:nvSpPr>
+          <p:cNvPr id="2" name="Title 1">
+            <a:extLst>
+              <a:ext uri="{FF2B5EF4-FFF2-40B4-BE49-F238E27FC236}">
+                <a16:creationId xmlns:a16="http://schemas.microsoft.com/office/drawing/2014/main" id="{B8339700-F67A-0A75-91F9-8BE0059732FF}"/>
+              </a:ext>
+            </a:extLst>
+          </p:cNvPr>
+          <p:cNvSpPr>
+            <a:spLocks noGrp="1"/>
+          </p:cNvSpPr>
+          <p:nvPr>
+            <p:ph type="title"/>
+          </p:nvPr>
+        </p:nvSpPr>
+        <p:spPr>
+          <a:xfrm>
+            <a:off x="152397" y="136526"/>
+            <a:ext cx="11861805" cy="2122580"/>
+          </a:xfrm>
+        </p:spPr>
+        <p:txBody>
+          <a:bodyPr anchor="t">
+            <a:normAutofit/>
+          </a:bodyPr>
+          <a:lstStyle/>
+          <a:p>
+            <a:r>
+              <a:rPr lang="en-US" dirty="0"/>
+              <a:t>Lab 2</a:t>
+            </a:r>
+            <a:br>
+              <a:rPr lang="en-US" dirty="0"/>
+            </a:br>
+            <a:r>
+              <a:rPr lang="en-US" dirty="0"/>
+              <a:t>Insert an FPGA in your PCB (quick preview)</a:t>
+            </a:r>
+          </a:p>
+        </p:txBody>
+      </p:sp>
+      <p:sp>
+        <p:nvSpPr>
+          <p:cNvPr id="3" name="Date Placeholder 2">
+            <a:extLst>
+              <a:ext uri="{FF2B5EF4-FFF2-40B4-BE49-F238E27FC236}">
+                <a16:creationId xmlns:a16="http://schemas.microsoft.com/office/drawing/2014/main" id="{259621BA-1EAF-7170-32E4-960BC7AAECEE}"/>
+              </a:ext>
+            </a:extLst>
+          </p:cNvPr>
+          <p:cNvSpPr>
+            <a:spLocks noGrp="1"/>
+          </p:cNvSpPr>
+          <p:nvPr>
+            <p:ph type="dt" sz="half" idx="10"/>
+          </p:nvPr>
+        </p:nvSpPr>
+        <p:spPr/>
+        <p:txBody>
+          <a:bodyPr/>
+          <a:lstStyle/>
+          <a:p>
+            <a:r>
+              <a:rPr lang="en-US"/>
+              <a:t>22/01/2026</a:t>
+            </a:r>
+          </a:p>
+        </p:txBody>
+      </p:sp>
+      <p:sp>
+        <p:nvSpPr>
+          <p:cNvPr id="4" name="Footer Placeholder 3">
+            <a:extLst>
+              <a:ext uri="{FF2B5EF4-FFF2-40B4-BE49-F238E27FC236}">
+                <a16:creationId xmlns:a16="http://schemas.microsoft.com/office/drawing/2014/main" id="{A7FBCC6C-0EA0-899D-4DDA-8C856891A448}"/>
+              </a:ext>
+            </a:extLst>
+          </p:cNvPr>
+          <p:cNvSpPr>
+            <a:spLocks noGrp="1"/>
+          </p:cNvSpPr>
+          <p:nvPr>
+            <p:ph type="ftr" sz="quarter" idx="11"/>
+          </p:nvPr>
+        </p:nvSpPr>
+        <p:spPr/>
+        <p:txBody>
+          <a:bodyPr/>
+          <a:lstStyle/>
+          <a:p>
+            <a:r>
+              <a:rPr lang="en-US"/>
+              <a:t>Stefan Cristi Zugravel, elettronica base, TPS lezione 5</a:t>
+            </a:r>
+          </a:p>
+        </p:txBody>
+      </p:sp>
+      <p:sp>
+        <p:nvSpPr>
+          <p:cNvPr id="5" name="Slide Number Placeholder 4">
+            <a:extLst>
+              <a:ext uri="{FF2B5EF4-FFF2-40B4-BE49-F238E27FC236}">
+                <a16:creationId xmlns:a16="http://schemas.microsoft.com/office/drawing/2014/main" id="{00CCD9BA-2C39-83C3-CA7F-88AE97892389}"/>
+              </a:ext>
+            </a:extLst>
+          </p:cNvPr>
+          <p:cNvSpPr>
+            <a:spLocks noGrp="1"/>
+          </p:cNvSpPr>
+          <p:nvPr>
+            <p:ph type="sldNum" sz="quarter" idx="12"/>
+          </p:nvPr>
+        </p:nvSpPr>
+        <p:spPr/>
+        <p:txBody>
+          <a:bodyPr/>
+          <a:lstStyle/>
+          <a:p>
+            <a:fld id="{B7C12E76-5DE4-834B-BE10-AD31AA7B20EC}" type="slidenum">
+              <a:rPr lang="en-US" smtClean="0"/>
+              <a:t>8</a:t>
+            </a:fld>
+            <a:endParaRPr lang="en-US"/>
+          </a:p>
+        </p:txBody>
+      </p:sp>
+    </p:spTree>
+    <p:extLst>
+      <p:ext uri="{BB962C8B-B14F-4D97-AF65-F5344CB8AC3E}">
+        <p14:creationId xmlns:p14="http://schemas.microsoft.com/office/powerpoint/2010/main" val="972663722"/>
+      </p:ext>
+    </p:extLst>
+  </p:cSld>
+  <p:clrMapOvr>
+    <a:masterClrMapping/>
+  </p:clrMapOvr>
+</p:sld>
+</file>
+
+<file path=ppt/slides/slide9.xml><?xml version="1.0" encoding="utf-8"?>
+<p:sld xmlns:a="http://schemas.openxmlformats.org/drawingml/2006/main" xmlns:r="http://schemas.openxmlformats.org/officeDocument/2006/relationships" xmlns:p="http://schemas.openxmlformats.org/presentationml/2006/main">
+  <p:cSld>
+    <p:spTree>
+      <p:nvGrpSpPr>
+        <p:cNvPr id="1" name="">
+          <a:extLst>
+            <a:ext uri="{FF2B5EF4-FFF2-40B4-BE49-F238E27FC236}">
+              <a16:creationId xmlns:a16="http://schemas.microsoft.com/office/drawing/2014/main" id="{94FB2B93-9B9F-DE5B-172D-B3906CB44FFD}"/>
+            </a:ext>
+          </a:extLst>
+        </p:cNvPr>
+        <p:cNvGrpSpPr/>
+        <p:nvPr/>
+      </p:nvGrpSpPr>
+      <p:grpSpPr>
+        <a:xfrm>
+          <a:off x="0" y="0"/>
+          <a:ext cx="0" cy="0"/>
+          <a:chOff x="0" y="0"/>
+          <a:chExt cx="0" cy="0"/>
+        </a:xfrm>
+      </p:grpSpPr>
+      <p:sp>
+        <p:nvSpPr>
+          <p:cNvPr id="2" name="Title 1">
+            <a:extLst>
+              <a:ext uri="{FF2B5EF4-FFF2-40B4-BE49-F238E27FC236}">
+                <a16:creationId xmlns:a16="http://schemas.microsoft.com/office/drawing/2014/main" id="{C575FA82-9023-9053-17F8-D875679810C8}"/>
+              </a:ext>
+            </a:extLst>
+          </p:cNvPr>
+          <p:cNvSpPr>
+            <a:spLocks noGrp="1"/>
+          </p:cNvSpPr>
+          <p:nvPr>
+            <p:ph type="title"/>
+          </p:nvPr>
+        </p:nvSpPr>
+        <p:spPr>
+          <a:xfrm>
+            <a:off x="152397" y="136526"/>
+            <a:ext cx="11861805" cy="2122580"/>
+          </a:xfrm>
+        </p:spPr>
+        <p:txBody>
+          <a:bodyPr anchor="t">
+            <a:normAutofit/>
+          </a:bodyPr>
+          <a:lstStyle/>
+          <a:p>
+            <a:r>
+              <a:rPr lang="en-US" dirty="0"/>
+              <a:t>Lab 3</a:t>
+            </a:r>
+            <a:br>
+              <a:rPr lang="en-US" dirty="0"/>
+            </a:br>
+            <a:r>
+              <a:rPr lang="en-US" dirty="0"/>
+              <a:t>Inverter, logic gates and mux in VHDL</a:t>
+            </a:r>
+          </a:p>
+        </p:txBody>
+      </p:sp>
+      <p:sp>
+        <p:nvSpPr>
+          <p:cNvPr id="3" name="Date Placeholder 2">
+            <a:extLst>
+              <a:ext uri="{FF2B5EF4-FFF2-40B4-BE49-F238E27FC236}">
+                <a16:creationId xmlns:a16="http://schemas.microsoft.com/office/drawing/2014/main" id="{F5ED7F95-90CA-6459-E69C-93144D840321}"/>
+              </a:ext>
+            </a:extLst>
+          </p:cNvPr>
+          <p:cNvSpPr>
+            <a:spLocks noGrp="1"/>
+          </p:cNvSpPr>
+          <p:nvPr>
+            <p:ph type="dt" sz="half" idx="10"/>
+          </p:nvPr>
+        </p:nvSpPr>
+        <p:spPr/>
+        <p:txBody>
+          <a:bodyPr/>
+          <a:lstStyle/>
+          <a:p>
+            <a:r>
+              <a:rPr lang="en-US"/>
+              <a:t>22/01/2026</a:t>
+            </a:r>
+          </a:p>
+        </p:txBody>
+      </p:sp>
+      <p:sp>
+        <p:nvSpPr>
+          <p:cNvPr id="4" name="Footer Placeholder 3">
+            <a:extLst>
+              <a:ext uri="{FF2B5EF4-FFF2-40B4-BE49-F238E27FC236}">
+                <a16:creationId xmlns:a16="http://schemas.microsoft.com/office/drawing/2014/main" id="{9C50AF90-D9AE-CEC0-9938-62285D6D9299}"/>
+              </a:ext>
+            </a:extLst>
+          </p:cNvPr>
+          <p:cNvSpPr>
+            <a:spLocks noGrp="1"/>
+          </p:cNvSpPr>
+          <p:nvPr>
+            <p:ph type="ftr" sz="quarter" idx="11"/>
+          </p:nvPr>
+        </p:nvSpPr>
+        <p:spPr/>
+        <p:txBody>
+          <a:bodyPr/>
+          <a:lstStyle/>
+          <a:p>
+            <a:r>
+              <a:rPr lang="en-US"/>
+              <a:t>Stefan Cristi Zugravel, elettronica base, TPS lezione 5</a:t>
+            </a:r>
+          </a:p>
+        </p:txBody>
+      </p:sp>
+      <p:sp>
+        <p:nvSpPr>
+          <p:cNvPr id="5" name="Slide Number Placeholder 4">
+            <a:extLst>
+              <a:ext uri="{FF2B5EF4-FFF2-40B4-BE49-F238E27FC236}">
+                <a16:creationId xmlns:a16="http://schemas.microsoft.com/office/drawing/2014/main" id="{9BF3FD0C-F063-A1DE-B970-C6EB29848081}"/>
+              </a:ext>
+            </a:extLst>
+          </p:cNvPr>
+          <p:cNvSpPr>
+            <a:spLocks noGrp="1"/>
+          </p:cNvSpPr>
+          <p:nvPr>
+            <p:ph type="sldNum" sz="quarter" idx="12"/>
+          </p:nvPr>
+        </p:nvSpPr>
+        <p:spPr/>
+        <p:txBody>
+          <a:bodyPr/>
+          <a:lstStyle/>
+          <a:p>
+            <a:fld id="{B7C12E76-5DE4-834B-BE10-AD31AA7B20EC}" type="slidenum">
+              <a:rPr lang="en-US" smtClean="0"/>
+              <a:t>9</a:t>
+            </a:fld>
+            <a:endParaRPr lang="en-US"/>
+          </a:p>
+        </p:txBody>
+      </p:sp>
+    </p:spTree>
+    <p:extLst>
+      <p:ext uri="{BB962C8B-B14F-4D97-AF65-F5344CB8AC3E}">
+        <p14:creationId xmlns:p14="http://schemas.microsoft.com/office/powerpoint/2010/main" val="3162619830"/>
       </p:ext>
     </p:extLst>
   </p:cSld>

</xml_diff>